<commit_message>
docs: refine EBAI capability layout
</commit_message>
<xml_diff>
--- a/docs/presentation/BAI-Work-Defense-Deck.pptx
+++ b/docs/presentation/BAI-Work-Defense-Deck.pptx
@@ -2,31 +2,31 @@
 <file path=ppt/presentation.xml><?xml version="1.0" encoding="utf-8"?>
 <p:presentation xmlns:p="http://schemas.openxmlformats.org/presentationml/2006/main">
   <p:sldMasterIdLst>
-    <p:sldMasterId xmlns:r="http://schemas.openxmlformats.org/officeDocument/2006/relationships" id="2147483648" r:id="R2bef834098ef4ab6"/>
+    <p:sldMasterId xmlns:r="http://schemas.openxmlformats.org/officeDocument/2006/relationships" id="2147483648" r:id="R09cf8de661424f8d"/>
   </p:sldMasterIdLst>
   <p:notesMasterIdLst>
-    <p:notesMasterId xmlns:r="http://schemas.openxmlformats.org/officeDocument/2006/relationships" r:id="Rbe2d5f20d4ec462f"/>
+    <p:notesMasterId xmlns:r="http://schemas.openxmlformats.org/officeDocument/2006/relationships" r:id="R91992c3af5f643b6"/>
   </p:notesMasterIdLst>
   <p:sldIdLst>
-    <p:sldId xmlns:r="http://schemas.openxmlformats.org/officeDocument/2006/relationships" id="256" r:id="R84e99ccaa4804594"/>
-    <p:sldId xmlns:r="http://schemas.openxmlformats.org/officeDocument/2006/relationships" id="257" r:id="R19eca8a186344a15"/>
-    <p:sldId xmlns:r="http://schemas.openxmlformats.org/officeDocument/2006/relationships" id="258" r:id="Rf31d9a52ac934149"/>
-    <p:sldId xmlns:r="http://schemas.openxmlformats.org/officeDocument/2006/relationships" id="259" r:id="Rdb74272636404daa"/>
-    <p:sldId xmlns:r="http://schemas.openxmlformats.org/officeDocument/2006/relationships" id="260" r:id="Rc02f8181407b4b0b"/>
-    <p:sldId xmlns:r="http://schemas.openxmlformats.org/officeDocument/2006/relationships" id="261" r:id="R03b8341de98d4504"/>
-    <p:sldId xmlns:r="http://schemas.openxmlformats.org/officeDocument/2006/relationships" id="262" r:id="R5dfbe5c0f5e644b3"/>
-    <p:sldId xmlns:r="http://schemas.openxmlformats.org/officeDocument/2006/relationships" id="263" r:id="Ra52d7254298046fc"/>
-    <p:sldId xmlns:r="http://schemas.openxmlformats.org/officeDocument/2006/relationships" id="264" r:id="Rfded3f76b9c14ff6"/>
-    <p:sldId xmlns:r="http://schemas.openxmlformats.org/officeDocument/2006/relationships" id="265" r:id="R318c78d3b5ef4653"/>
-    <p:sldId xmlns:r="http://schemas.openxmlformats.org/officeDocument/2006/relationships" id="266" r:id="Rc39a4999e8244796"/>
-    <p:sldId xmlns:r="http://schemas.openxmlformats.org/officeDocument/2006/relationships" id="267" r:id="R5d524ca92dec43e5"/>
-    <p:sldId xmlns:r="http://schemas.openxmlformats.org/officeDocument/2006/relationships" id="268" r:id="R9d990a921eae416e"/>
-    <p:sldId xmlns:r="http://schemas.openxmlformats.org/officeDocument/2006/relationships" id="269" r:id="R08bfed3c5a1048d3"/>
-    <p:sldId xmlns:r="http://schemas.openxmlformats.org/officeDocument/2006/relationships" id="270" r:id="R29ab08167b4f4e0a"/>
-    <p:sldId xmlns:r="http://schemas.openxmlformats.org/officeDocument/2006/relationships" id="271" r:id="R292a062ff8b24f7c"/>
-    <p:sldId xmlns:r="http://schemas.openxmlformats.org/officeDocument/2006/relationships" id="272" r:id="R72c7ef18eb8442db"/>
-    <p:sldId xmlns:r="http://schemas.openxmlformats.org/officeDocument/2006/relationships" id="273" r:id="Rc51e675b72b149cc"/>
-    <p:sldId xmlns:r="http://schemas.openxmlformats.org/officeDocument/2006/relationships" id="274" r:id="Rbfa48fa78d3542fc"/>
+    <p:sldId xmlns:r="http://schemas.openxmlformats.org/officeDocument/2006/relationships" id="256" r:id="Rded74b8a78ac46a4"/>
+    <p:sldId xmlns:r="http://schemas.openxmlformats.org/officeDocument/2006/relationships" id="257" r:id="Rb271a2955fbe4047"/>
+    <p:sldId xmlns:r="http://schemas.openxmlformats.org/officeDocument/2006/relationships" id="258" r:id="R0b111f065e724cb6"/>
+    <p:sldId xmlns:r="http://schemas.openxmlformats.org/officeDocument/2006/relationships" id="259" r:id="R256b3676f3804576"/>
+    <p:sldId xmlns:r="http://schemas.openxmlformats.org/officeDocument/2006/relationships" id="260" r:id="Rb11ae6d16a30446a"/>
+    <p:sldId xmlns:r="http://schemas.openxmlformats.org/officeDocument/2006/relationships" id="261" r:id="R3880ab20c45a49c9"/>
+    <p:sldId xmlns:r="http://schemas.openxmlformats.org/officeDocument/2006/relationships" id="262" r:id="Re69ed6a2e61f499a"/>
+    <p:sldId xmlns:r="http://schemas.openxmlformats.org/officeDocument/2006/relationships" id="263" r:id="R89331e24dbca4021"/>
+    <p:sldId xmlns:r="http://schemas.openxmlformats.org/officeDocument/2006/relationships" id="264" r:id="R199129d2ce8a4589"/>
+    <p:sldId xmlns:r="http://schemas.openxmlformats.org/officeDocument/2006/relationships" id="265" r:id="R7b2f3941c6cf4f19"/>
+    <p:sldId xmlns:r="http://schemas.openxmlformats.org/officeDocument/2006/relationships" id="266" r:id="R0d08bacfc939448f"/>
+    <p:sldId xmlns:r="http://schemas.openxmlformats.org/officeDocument/2006/relationships" id="267" r:id="R80816e21b941434d"/>
+    <p:sldId xmlns:r="http://schemas.openxmlformats.org/officeDocument/2006/relationships" id="268" r:id="R8d1ed3189e2c4b61"/>
+    <p:sldId xmlns:r="http://schemas.openxmlformats.org/officeDocument/2006/relationships" id="269" r:id="R8dfd8e89cb894f85"/>
+    <p:sldId xmlns:r="http://schemas.openxmlformats.org/officeDocument/2006/relationships" id="270" r:id="R695f6666eb654e2a"/>
+    <p:sldId xmlns:r="http://schemas.openxmlformats.org/officeDocument/2006/relationships" id="271" r:id="R5c156f8fbd6e4f82"/>
+    <p:sldId xmlns:r="http://schemas.openxmlformats.org/officeDocument/2006/relationships" id="272" r:id="Rb723a155b2f4411d"/>
+    <p:sldId xmlns:r="http://schemas.openxmlformats.org/officeDocument/2006/relationships" id="273" r:id="R7ab8770fb89a45d7"/>
+    <p:sldId xmlns:r="http://schemas.openxmlformats.org/officeDocument/2006/relationships" id="274" r:id="R5bf652ca74e1439d"/>
   </p:sldIdLst>
   <p:sldSz cx="12191695" cy="6858000"/>
   <p:notesSz cx="6858000" cy="9144000"/>
@@ -2117,7 +2117,7 @@
   </p:cSld>
   <p:clrMap bg1="lt1" tx1="dk1" bg2="lt2" tx2="dk2" accent1="accent1" accent2="accent2" accent3="accent3" accent4="accent4" accent5="accent5" accent6="accent6" hlink="hlink" folHlink="folHlink"/>
   <p:sldLayoutIdLst>
-    <p:sldLayoutId xmlns:r="http://schemas.openxmlformats.org/officeDocument/2006/relationships" id="2147483649" r:id="Re0a63b8a47c147d5"/>
+    <p:sldLayoutId xmlns:r="http://schemas.openxmlformats.org/officeDocument/2006/relationships" id="2147483649" r:id="R14168b18945f4e29"/>
   </p:sldLayoutIdLst>
   <p:hf sldNum="0" hdr="0" ftr="0" dt="0"/>
   <p:txStyles>
@@ -2760,7 +2760,7 @@
           <p:nvPr/>
         </p:nvPicPr>
         <p:blipFill>
-          <a:blip xmlns:r="http://schemas.openxmlformats.org/officeDocument/2006/relationships" xmlns:a="http://schemas.openxmlformats.org/drawingml/2006/main" r:embed="Rfebb3873a0eb4ca1"/>
+          <a:blip xmlns:r="http://schemas.openxmlformats.org/officeDocument/2006/relationships" xmlns:a="http://schemas.openxmlformats.org/drawingml/2006/main" r:embed="R85dbab4045544d19"/>
           <a:stretch xmlns:a="http://schemas.openxmlformats.org/drawingml/2006/main">
             <a:fillRect l="0" t="0" r="0" b="0"/>
           </a:stretch>
@@ -2944,7 +2944,7 @@
           <p:nvPr/>
         </p:nvPicPr>
         <p:blipFill>
-          <a:blip xmlns:r="http://schemas.openxmlformats.org/officeDocument/2006/relationships" xmlns:a="http://schemas.openxmlformats.org/drawingml/2006/main" r:embed="R45a1dc828de9498e"/>
+          <a:blip xmlns:r="http://schemas.openxmlformats.org/officeDocument/2006/relationships" xmlns:a="http://schemas.openxmlformats.org/drawingml/2006/main" r:embed="R62afd280445c4303"/>
           <a:stretch xmlns:a="http://schemas.openxmlformats.org/drawingml/2006/main">
             <a:fillRect l="0" t="0" r="0" b="0"/>
           </a:stretch>
@@ -5183,8 +5183,8 @@
         </p:nvSpPr>
         <p:spPr>
           <a:xfrm xmlns:a="http://schemas.openxmlformats.org/drawingml/2006/main">
-            <a:off x="502920" y="1810512"/>
-            <a:ext cx="1554480" cy="1481328"/>
+            <a:off x="658368" y="1572768"/>
+            <a:ext cx="10863072" cy="640080"/>
           </a:xfrm>
           <a:prstGeom xmlns:a="http://schemas.openxmlformats.org/drawingml/2006/main" prst="roundRect">
             <a:avLst>
@@ -5218,8 +5218,8 @@
         </p:nvSpPr>
         <p:spPr>
           <a:xfrm xmlns:a="http://schemas.openxmlformats.org/drawingml/2006/main">
-            <a:off x="594360" y="2029968"/>
-            <a:ext cx="1371600" cy="310896"/>
+            <a:off x="896112" y="1737360"/>
+            <a:ext cx="1097280" cy="310896"/>
           </a:xfrm>
           <a:prstGeom xmlns:a="http://schemas.openxmlformats.org/drawingml/2006/main" prst="rect">
             <a:avLst/>
@@ -5265,8 +5265,8 @@
         </p:nvSpPr>
         <p:spPr>
           <a:xfrm xmlns:a="http://schemas.openxmlformats.org/drawingml/2006/main">
-            <a:off x="612648" y="2542032"/>
-            <a:ext cx="1335024" cy="512064"/>
+            <a:off x="2084832" y="1645920"/>
+            <a:ext cx="9070848" cy="438912"/>
           </a:xfrm>
           <a:prstGeom xmlns:a="http://schemas.openxmlformats.org/drawingml/2006/main" prst="rect">
             <a:avLst/>
@@ -5328,8 +5328,8 @@
         </p:nvSpPr>
         <p:spPr>
           <a:xfrm xmlns:a="http://schemas.openxmlformats.org/drawingml/2006/main">
-            <a:off x="2404872" y="1810512"/>
-            <a:ext cx="1554480" cy="1481328"/>
+            <a:off x="658368" y="2414016"/>
+            <a:ext cx="1997050" cy="1261872"/>
           </a:xfrm>
           <a:prstGeom xmlns:a="http://schemas.openxmlformats.org/drawingml/2006/main" prst="roundRect">
             <a:avLst>
@@ -5363,8 +5363,8 @@
         </p:nvSpPr>
         <p:spPr>
           <a:xfrm xmlns:a="http://schemas.openxmlformats.org/drawingml/2006/main">
-            <a:off x="2496312" y="2029968"/>
-            <a:ext cx="1371600" cy="310896"/>
+            <a:off x="768096" y="2624328"/>
+            <a:ext cx="1777594" cy="310896"/>
           </a:xfrm>
           <a:prstGeom xmlns:a="http://schemas.openxmlformats.org/drawingml/2006/main" prst="rect">
             <a:avLst/>
@@ -5410,8 +5410,8 @@
         </p:nvSpPr>
         <p:spPr>
           <a:xfrm xmlns:a="http://schemas.openxmlformats.org/drawingml/2006/main">
-            <a:off x="2514600" y="2542032"/>
-            <a:ext cx="1335024" cy="512064"/>
+            <a:off x="804672" y="3026664"/>
+            <a:ext cx="1704442" cy="512064"/>
           </a:xfrm>
           <a:prstGeom xmlns:a="http://schemas.openxmlformats.org/drawingml/2006/main" prst="rect">
             <a:avLst/>
@@ -5473,8 +5473,8 @@
         </p:nvSpPr>
         <p:spPr>
           <a:xfrm xmlns:a="http://schemas.openxmlformats.org/drawingml/2006/main">
-            <a:off x="4306824" y="1810512"/>
-            <a:ext cx="1554480" cy="1481328"/>
+            <a:off x="2874874" y="2414016"/>
+            <a:ext cx="1997050" cy="1261872"/>
           </a:xfrm>
           <a:prstGeom xmlns:a="http://schemas.openxmlformats.org/drawingml/2006/main" prst="roundRect">
             <a:avLst>
@@ -5508,8 +5508,8 @@
         </p:nvSpPr>
         <p:spPr>
           <a:xfrm xmlns:a="http://schemas.openxmlformats.org/drawingml/2006/main">
-            <a:off x="4398264" y="2029968"/>
-            <a:ext cx="1371600" cy="310896"/>
+            <a:off x="2984602" y="2624328"/>
+            <a:ext cx="1777594" cy="310896"/>
           </a:xfrm>
           <a:prstGeom xmlns:a="http://schemas.openxmlformats.org/drawingml/2006/main" prst="rect">
             <a:avLst/>
@@ -5555,8 +5555,8 @@
         </p:nvSpPr>
         <p:spPr>
           <a:xfrm xmlns:a="http://schemas.openxmlformats.org/drawingml/2006/main">
-            <a:off x="4416552" y="2542032"/>
-            <a:ext cx="1335024" cy="512064"/>
+            <a:off x="3021178" y="3026664"/>
+            <a:ext cx="1704442" cy="512064"/>
           </a:xfrm>
           <a:prstGeom xmlns:a="http://schemas.openxmlformats.org/drawingml/2006/main" prst="rect">
             <a:avLst/>
@@ -5618,8 +5618,8 @@
         </p:nvSpPr>
         <p:spPr>
           <a:xfrm xmlns:a="http://schemas.openxmlformats.org/drawingml/2006/main">
-            <a:off x="6208776" y="1810512"/>
-            <a:ext cx="1554480" cy="1481328"/>
+            <a:off x="5091379" y="2414016"/>
+            <a:ext cx="1997050" cy="1261872"/>
           </a:xfrm>
           <a:prstGeom xmlns:a="http://schemas.openxmlformats.org/drawingml/2006/main" prst="roundRect">
             <a:avLst>
@@ -5653,8 +5653,8 @@
         </p:nvSpPr>
         <p:spPr>
           <a:xfrm xmlns:a="http://schemas.openxmlformats.org/drawingml/2006/main">
-            <a:off x="6300216" y="2029968"/>
-            <a:ext cx="1371600" cy="310896"/>
+            <a:off x="5201107" y="2624328"/>
+            <a:ext cx="1777594" cy="310896"/>
           </a:xfrm>
           <a:prstGeom xmlns:a="http://schemas.openxmlformats.org/drawingml/2006/main" prst="rect">
             <a:avLst/>
@@ -5700,8 +5700,8 @@
         </p:nvSpPr>
         <p:spPr>
           <a:xfrm xmlns:a="http://schemas.openxmlformats.org/drawingml/2006/main">
-            <a:off x="6318504" y="2542032"/>
-            <a:ext cx="1335024" cy="512064"/>
+            <a:off x="5237683" y="3026664"/>
+            <a:ext cx="1704442" cy="512064"/>
           </a:xfrm>
           <a:prstGeom xmlns:a="http://schemas.openxmlformats.org/drawingml/2006/main" prst="rect">
             <a:avLst/>
@@ -5763,8 +5763,8 @@
         </p:nvSpPr>
         <p:spPr>
           <a:xfrm xmlns:a="http://schemas.openxmlformats.org/drawingml/2006/main">
-            <a:off x="8110728" y="1810512"/>
-            <a:ext cx="1554480" cy="1481328"/>
+            <a:off x="7307885" y="2414016"/>
+            <a:ext cx="1997050" cy="1261872"/>
           </a:xfrm>
           <a:prstGeom xmlns:a="http://schemas.openxmlformats.org/drawingml/2006/main" prst="roundRect">
             <a:avLst>
@@ -5798,8 +5798,8 @@
         </p:nvSpPr>
         <p:spPr>
           <a:xfrm xmlns:a="http://schemas.openxmlformats.org/drawingml/2006/main">
-            <a:off x="8202168" y="2029968"/>
-            <a:ext cx="1371600" cy="310896"/>
+            <a:off x="7417613" y="2624328"/>
+            <a:ext cx="1777594" cy="310896"/>
           </a:xfrm>
           <a:prstGeom xmlns:a="http://schemas.openxmlformats.org/drawingml/2006/main" prst="rect">
             <a:avLst/>
@@ -5845,8 +5845,8 @@
         </p:nvSpPr>
         <p:spPr>
           <a:xfrm xmlns:a="http://schemas.openxmlformats.org/drawingml/2006/main">
-            <a:off x="8220456" y="2542032"/>
-            <a:ext cx="1335024" cy="512064"/>
+            <a:off x="7454189" y="3026664"/>
+            <a:ext cx="1704442" cy="512064"/>
           </a:xfrm>
           <a:prstGeom xmlns:a="http://schemas.openxmlformats.org/drawingml/2006/main" prst="rect">
             <a:avLst/>
@@ -5908,8 +5908,8 @@
         </p:nvSpPr>
         <p:spPr>
           <a:xfrm xmlns:a="http://schemas.openxmlformats.org/drawingml/2006/main">
-            <a:off x="10012680" y="1810512"/>
-            <a:ext cx="1554480" cy="1481328"/>
+            <a:off x="9524390" y="2414016"/>
+            <a:ext cx="1997050" cy="1261872"/>
           </a:xfrm>
           <a:prstGeom xmlns:a="http://schemas.openxmlformats.org/drawingml/2006/main" prst="roundRect">
             <a:avLst>
@@ -5943,8 +5943,8 @@
         </p:nvSpPr>
         <p:spPr>
           <a:xfrm xmlns:a="http://schemas.openxmlformats.org/drawingml/2006/main">
-            <a:off x="10104120" y="2029968"/>
-            <a:ext cx="1371600" cy="310896"/>
+            <a:off x="9634118" y="2624328"/>
+            <a:ext cx="1777594" cy="310896"/>
           </a:xfrm>
           <a:prstGeom xmlns:a="http://schemas.openxmlformats.org/drawingml/2006/main" prst="rect">
             <a:avLst/>
@@ -5990,8 +5990,8 @@
         </p:nvSpPr>
         <p:spPr>
           <a:xfrm xmlns:a="http://schemas.openxmlformats.org/drawingml/2006/main">
-            <a:off x="10122408" y="2542032"/>
-            <a:ext cx="1335024" cy="512064"/>
+            <a:off x="9670694" y="3026664"/>
+            <a:ext cx="1704442" cy="512064"/>
           </a:xfrm>
           <a:prstGeom xmlns:a="http://schemas.openxmlformats.org/drawingml/2006/main" prst="rect">
             <a:avLst/>
@@ -6053,8 +6053,8 @@
         </p:nvSpPr>
         <p:spPr>
           <a:xfrm xmlns:a="http://schemas.openxmlformats.org/drawingml/2006/main">
-            <a:off x="658368" y="3794760"/>
-            <a:ext cx="5212080" cy="1554480"/>
+            <a:off x="658368" y="3895344"/>
+            <a:ext cx="5212080" cy="1499616"/>
           </a:xfrm>
           <a:prstGeom xmlns:a="http://schemas.openxmlformats.org/drawingml/2006/main" prst="roundRect">
             <a:avLst>
@@ -6088,17 +6088,17 @@
         </p:nvSpPr>
         <p:spPr>
           <a:xfrm xmlns:a="http://schemas.openxmlformats.org/drawingml/2006/main">
-            <a:off x="896112" y="4059936"/>
-            <a:ext cx="914400" cy="274320"/>
-          </a:xfrm>
-          <a:prstGeom xmlns:a="http://schemas.openxmlformats.org/drawingml/2006/main" prst="rect">
-            <a:avLst/>
-          </a:prstGeom>
-          <a:noFill xmlns:a="http://schemas.openxmlformats.org/drawingml/2006/main"/>
-        </p:spPr>
-        <p:txBody>
-          <a:bodyPr xmlns:a="http://schemas.openxmlformats.org/drawingml/2006/main" wrap="square" lIns="0" tIns="0" rIns="0" bIns="0" anchor="ctr">
-            <a:normAutofit fontScale="86172"/>
+            <a:off x="896112" y="4069080"/>
+            <a:ext cx="1828800" cy="292608"/>
+          </a:xfrm>
+          <a:prstGeom xmlns:a="http://schemas.openxmlformats.org/drawingml/2006/main" prst="rect">
+            <a:avLst/>
+          </a:prstGeom>
+          <a:noFill xmlns:a="http://schemas.openxmlformats.org/drawingml/2006/main"/>
+        </p:spPr>
+        <p:txBody>
+          <a:bodyPr xmlns:a="http://schemas.openxmlformats.org/drawingml/2006/main" wrap="square" lIns="0" tIns="0" rIns="0" bIns="0" anchor="ctr">
+            <a:normAutofit fontScale="100000"/>
           </a:bodyPr>
           <a:lstStyle xmlns:a="http://schemas.openxmlformats.org/drawingml/2006/main"/>
           <a:p xmlns:a="http://schemas.openxmlformats.org/drawingml/2006/main">
@@ -6135,7 +6135,7 @@
         </p:nvSpPr>
         <p:spPr>
           <a:xfrm xmlns:a="http://schemas.openxmlformats.org/drawingml/2006/main">
-            <a:off x="1874520" y="4123944"/>
+            <a:off x="932688" y="4526280"/>
             <a:ext cx="73152" cy="73152"/>
           </a:xfrm>
           <a:prstGeom xmlns:a="http://schemas.openxmlformats.org/drawingml/2006/main" prst="rect">
@@ -6168,8 +6168,8 @@
         </p:nvSpPr>
         <p:spPr>
           <a:xfrm xmlns:a="http://schemas.openxmlformats.org/drawingml/2006/main">
-            <a:off x="2057400" y="3986784"/>
-            <a:ext cx="3474720" cy="393192"/>
+            <a:off x="1115568" y="4389120"/>
+            <a:ext cx="4434840" cy="329184"/>
           </a:xfrm>
           <a:prstGeom xmlns:a="http://schemas.openxmlformats.org/drawingml/2006/main" prst="rect">
             <a:avLst/>
@@ -6215,7 +6215,7 @@
         </p:nvSpPr>
         <p:spPr>
           <a:xfrm xmlns:a="http://schemas.openxmlformats.org/drawingml/2006/main">
-            <a:off x="1874520" y="4517136"/>
+            <a:off x="932688" y="4855464"/>
             <a:ext cx="73152" cy="73152"/>
           </a:xfrm>
           <a:prstGeom xmlns:a="http://schemas.openxmlformats.org/drawingml/2006/main" prst="rect">
@@ -6248,8 +6248,8 @@
         </p:nvSpPr>
         <p:spPr>
           <a:xfrm xmlns:a="http://schemas.openxmlformats.org/drawingml/2006/main">
-            <a:off x="2057400" y="4379976"/>
-            <a:ext cx="3474720" cy="393192"/>
+            <a:off x="1115568" y="4718304"/>
+            <a:ext cx="4434840" cy="329184"/>
           </a:xfrm>
           <a:prstGeom xmlns:a="http://schemas.openxmlformats.org/drawingml/2006/main" prst="rect">
             <a:avLst/>
@@ -6295,7 +6295,7 @@
         </p:nvSpPr>
         <p:spPr>
           <a:xfrm xmlns:a="http://schemas.openxmlformats.org/drawingml/2006/main">
-            <a:off x="1874520" y="4910328"/>
+            <a:off x="932688" y="5184648"/>
             <a:ext cx="73152" cy="73152"/>
           </a:xfrm>
           <a:prstGeom xmlns:a="http://schemas.openxmlformats.org/drawingml/2006/main" prst="rect">
@@ -6328,8 +6328,8 @@
         </p:nvSpPr>
         <p:spPr>
           <a:xfrm xmlns:a="http://schemas.openxmlformats.org/drawingml/2006/main">
-            <a:off x="2057400" y="4773168"/>
-            <a:ext cx="3474720" cy="393192"/>
+            <a:off x="1115568" y="5047488"/>
+            <a:ext cx="4434840" cy="329184"/>
           </a:xfrm>
           <a:prstGeom xmlns:a="http://schemas.openxmlformats.org/drawingml/2006/main" prst="rect">
             <a:avLst/>
@@ -6375,8 +6375,8 @@
         </p:nvSpPr>
         <p:spPr>
           <a:xfrm xmlns:a="http://schemas.openxmlformats.org/drawingml/2006/main">
-            <a:off x="6144768" y="3794760"/>
-            <a:ext cx="5376672" cy="1554480"/>
+            <a:off x="6144768" y="3895344"/>
+            <a:ext cx="5376672" cy="1499616"/>
           </a:xfrm>
           <a:prstGeom xmlns:a="http://schemas.openxmlformats.org/drawingml/2006/main" prst="roundRect">
             <a:avLst>
@@ -6410,8 +6410,8 @@
         </p:nvSpPr>
         <p:spPr>
           <a:xfrm xmlns:a="http://schemas.openxmlformats.org/drawingml/2006/main">
-            <a:off x="6419088" y="4059936"/>
-            <a:ext cx="914400" cy="274320"/>
+            <a:off x="6419088" y="4069080"/>
+            <a:ext cx="1828800" cy="292608"/>
           </a:xfrm>
           <a:prstGeom xmlns:a="http://schemas.openxmlformats.org/drawingml/2006/main" prst="rect">
             <a:avLst/>
@@ -6457,8 +6457,8 @@
         </p:nvSpPr>
         <p:spPr>
           <a:xfrm xmlns:a="http://schemas.openxmlformats.org/drawingml/2006/main">
-            <a:off x="7589520" y="3950208"/>
-            <a:ext cx="3584448" cy="1024128"/>
+            <a:off x="6419088" y="4407408"/>
+            <a:ext cx="4709160" cy="868680"/>
           </a:xfrm>
           <a:prstGeom xmlns:a="http://schemas.openxmlformats.org/drawingml/2006/main" prst="rect">
             <a:avLst/>
@@ -6552,7 +6552,7 @@
         </p:nvSpPr>
         <p:spPr>
           <a:xfrm xmlns:a="http://schemas.openxmlformats.org/drawingml/2006/main">
-            <a:off x="1115568" y="5797296"/>
+            <a:off x="1115568" y="5715000"/>
             <a:ext cx="9966960" cy="384048"/>
           </a:xfrm>
           <a:prstGeom xmlns:a="http://schemas.openxmlformats.org/drawingml/2006/main" prst="rect">
@@ -18801,7 +18801,7 @@
           <p:nvPr/>
         </p:nvPicPr>
         <p:blipFill>
-          <a:blip xmlns:r="http://schemas.openxmlformats.org/officeDocument/2006/relationships" xmlns:a="http://schemas.openxmlformats.org/drawingml/2006/main" r:embed="Re80984e9c8f5426f"/>
+          <a:blip xmlns:r="http://schemas.openxmlformats.org/officeDocument/2006/relationships" xmlns:a="http://schemas.openxmlformats.org/drawingml/2006/main" r:embed="Rd2a14afea1ff4908"/>
           <a:stretch xmlns:a="http://schemas.openxmlformats.org/drawingml/2006/main">
             <a:fillRect l="0" t="0" r="0" b="0"/>
           </a:stretch>
@@ -23113,7 +23113,7 @@
           <p:nvPr/>
         </p:nvPicPr>
         <p:blipFill>
-          <a:blip xmlns:r="http://schemas.openxmlformats.org/officeDocument/2006/relationships" xmlns:a="http://schemas.openxmlformats.org/drawingml/2006/main" r:embed="R3836e384553347fb"/>
+          <a:blip xmlns:r="http://schemas.openxmlformats.org/officeDocument/2006/relationships" xmlns:a="http://schemas.openxmlformats.org/drawingml/2006/main" r:embed="R25b0caefd9cb475d"/>
           <a:stretch xmlns:a="http://schemas.openxmlformats.org/drawingml/2006/main">
             <a:fillRect l="0" t="0" r="0" b="0"/>
           </a:stretch>

</xml_diff>

<commit_message>
docs: add local user value positioning
</commit_message>
<xml_diff>
--- a/docs/presentation/BAI-Work-Defense-Deck.pptx
+++ b/docs/presentation/BAI-Work-Defense-Deck.pptx
@@ -2,31 +2,31 @@
 <file path=ppt/presentation.xml><?xml version="1.0" encoding="utf-8"?>
 <p:presentation xmlns:p="http://schemas.openxmlformats.org/presentationml/2006/main">
   <p:sldMasterIdLst>
-    <p:sldMasterId xmlns:r="http://schemas.openxmlformats.org/officeDocument/2006/relationships" id="2147483648" r:id="R09cf8de661424f8d"/>
+    <p:sldMasterId xmlns:r="http://schemas.openxmlformats.org/officeDocument/2006/relationships" id="2147483648" r:id="R1a812313b94645f9"/>
   </p:sldMasterIdLst>
   <p:notesMasterIdLst>
-    <p:notesMasterId xmlns:r="http://schemas.openxmlformats.org/officeDocument/2006/relationships" r:id="R91992c3af5f643b6"/>
+    <p:notesMasterId xmlns:r="http://schemas.openxmlformats.org/officeDocument/2006/relationships" r:id="R7c62846fe3d841f3"/>
   </p:notesMasterIdLst>
   <p:sldIdLst>
-    <p:sldId xmlns:r="http://schemas.openxmlformats.org/officeDocument/2006/relationships" id="256" r:id="Rded74b8a78ac46a4"/>
-    <p:sldId xmlns:r="http://schemas.openxmlformats.org/officeDocument/2006/relationships" id="257" r:id="Rb271a2955fbe4047"/>
-    <p:sldId xmlns:r="http://schemas.openxmlformats.org/officeDocument/2006/relationships" id="258" r:id="R0b111f065e724cb6"/>
-    <p:sldId xmlns:r="http://schemas.openxmlformats.org/officeDocument/2006/relationships" id="259" r:id="R256b3676f3804576"/>
-    <p:sldId xmlns:r="http://schemas.openxmlformats.org/officeDocument/2006/relationships" id="260" r:id="Rb11ae6d16a30446a"/>
-    <p:sldId xmlns:r="http://schemas.openxmlformats.org/officeDocument/2006/relationships" id="261" r:id="R3880ab20c45a49c9"/>
-    <p:sldId xmlns:r="http://schemas.openxmlformats.org/officeDocument/2006/relationships" id="262" r:id="Re69ed6a2e61f499a"/>
-    <p:sldId xmlns:r="http://schemas.openxmlformats.org/officeDocument/2006/relationships" id="263" r:id="R89331e24dbca4021"/>
-    <p:sldId xmlns:r="http://schemas.openxmlformats.org/officeDocument/2006/relationships" id="264" r:id="R199129d2ce8a4589"/>
-    <p:sldId xmlns:r="http://schemas.openxmlformats.org/officeDocument/2006/relationships" id="265" r:id="R7b2f3941c6cf4f19"/>
-    <p:sldId xmlns:r="http://schemas.openxmlformats.org/officeDocument/2006/relationships" id="266" r:id="R0d08bacfc939448f"/>
-    <p:sldId xmlns:r="http://schemas.openxmlformats.org/officeDocument/2006/relationships" id="267" r:id="R80816e21b941434d"/>
-    <p:sldId xmlns:r="http://schemas.openxmlformats.org/officeDocument/2006/relationships" id="268" r:id="R8d1ed3189e2c4b61"/>
-    <p:sldId xmlns:r="http://schemas.openxmlformats.org/officeDocument/2006/relationships" id="269" r:id="R8dfd8e89cb894f85"/>
-    <p:sldId xmlns:r="http://schemas.openxmlformats.org/officeDocument/2006/relationships" id="270" r:id="R695f6666eb654e2a"/>
-    <p:sldId xmlns:r="http://schemas.openxmlformats.org/officeDocument/2006/relationships" id="271" r:id="R5c156f8fbd6e4f82"/>
-    <p:sldId xmlns:r="http://schemas.openxmlformats.org/officeDocument/2006/relationships" id="272" r:id="Rb723a155b2f4411d"/>
-    <p:sldId xmlns:r="http://schemas.openxmlformats.org/officeDocument/2006/relationships" id="273" r:id="R7ab8770fb89a45d7"/>
-    <p:sldId xmlns:r="http://schemas.openxmlformats.org/officeDocument/2006/relationships" id="274" r:id="R5bf652ca74e1439d"/>
+    <p:sldId xmlns:r="http://schemas.openxmlformats.org/officeDocument/2006/relationships" id="256" r:id="Rb53195806adf446c"/>
+    <p:sldId xmlns:r="http://schemas.openxmlformats.org/officeDocument/2006/relationships" id="257" r:id="Rfb156c62d59d4c50"/>
+    <p:sldId xmlns:r="http://schemas.openxmlformats.org/officeDocument/2006/relationships" id="258" r:id="Rdcb7060b842b4b30"/>
+    <p:sldId xmlns:r="http://schemas.openxmlformats.org/officeDocument/2006/relationships" id="259" r:id="Rfe7c3555b664477c"/>
+    <p:sldId xmlns:r="http://schemas.openxmlformats.org/officeDocument/2006/relationships" id="260" r:id="Rac5c5cdc7c6e4024"/>
+    <p:sldId xmlns:r="http://schemas.openxmlformats.org/officeDocument/2006/relationships" id="261" r:id="Rc1a95a62ed204b48"/>
+    <p:sldId xmlns:r="http://schemas.openxmlformats.org/officeDocument/2006/relationships" id="262" r:id="Ra37fc7dcbc6149de"/>
+    <p:sldId xmlns:r="http://schemas.openxmlformats.org/officeDocument/2006/relationships" id="263" r:id="R5c8fa9984c764dcb"/>
+    <p:sldId xmlns:r="http://schemas.openxmlformats.org/officeDocument/2006/relationships" id="264" r:id="R187021781aa64d61"/>
+    <p:sldId xmlns:r="http://schemas.openxmlformats.org/officeDocument/2006/relationships" id="265" r:id="R96b7b273acbd4770"/>
+    <p:sldId xmlns:r="http://schemas.openxmlformats.org/officeDocument/2006/relationships" id="266" r:id="R3b3cb4782a414c14"/>
+    <p:sldId xmlns:r="http://schemas.openxmlformats.org/officeDocument/2006/relationships" id="267" r:id="R15f3a89f494f4623"/>
+    <p:sldId xmlns:r="http://schemas.openxmlformats.org/officeDocument/2006/relationships" id="268" r:id="Ra420fcf5042e42c5"/>
+    <p:sldId xmlns:r="http://schemas.openxmlformats.org/officeDocument/2006/relationships" id="269" r:id="Rb18f842ec1784f14"/>
+    <p:sldId xmlns:r="http://schemas.openxmlformats.org/officeDocument/2006/relationships" id="270" r:id="R762a670a5186416f"/>
+    <p:sldId xmlns:r="http://schemas.openxmlformats.org/officeDocument/2006/relationships" id="271" r:id="Rd76e192d7ee44017"/>
+    <p:sldId xmlns:r="http://schemas.openxmlformats.org/officeDocument/2006/relationships" id="272" r:id="Rc7152f22fded4656"/>
+    <p:sldId xmlns:r="http://schemas.openxmlformats.org/officeDocument/2006/relationships" id="273" r:id="Rdf12a285e5b944cf"/>
+    <p:sldId xmlns:r="http://schemas.openxmlformats.org/officeDocument/2006/relationships" id="274" r:id="R3bf5e05478064114"/>
   </p:sldIdLst>
   <p:sldSz cx="12191695" cy="6858000"/>
   <p:notesSz cx="6858000" cy="9144000"/>
@@ -1176,10 +1176,27 @@
           <a:lstStyle xmlns:a="http://schemas.openxmlformats.org/drawingml/2006/main"/>
           <a:p xmlns:a="http://schemas.openxmlformats.org/drawingml/2006/main">
             <a:r>
-              <a:t>目标用户（建议 35 秒）
-首批用户是有真实本地项目、长任务和产物验收需求的个人与小团队。
-BAI 生态用户获得的是持续桌面入口和项目交付工作面。
-切入策略先验证高频留存与任务完成率，再扩展更广泛场景。</a:t>
+              <a:t>本地化用户价值（建议 40 秒）</a:t>
+            </a:r>
+          </a:p>
+          <a:p xmlns:a="http://schemas.openxmlformats.org/drawingml/2006/main">
+            <a:r>
+              <a:t>不做未经验证的比例判断；重点是许多普通用户从问答进入任务交付时，仍面对持续推进与产物验收的门槛。</a:t>
+            </a:r>
+          </a:p>
+          <a:p xmlns:a="http://schemas.openxmlformats.org/drawingml/2006/main">
+            <a:r>
+              <a:t>BAI Work 把上下文、工具、进度、产物和验证收进同一工作面，让用户获得可直接使用的成果。</a:t>
+            </a:r>
+          </a:p>
+          <a:p xmlns:a="http://schemas.openxmlformats.org/drawingml/2006/main">
+            <a:r>
+              <a:t>当前 BAI provider preset 包含 Claude 与 GPT 系列模型；用户通过已获授权的 API Key 使用，具体能力以实际可用性和相关条款为准。</a:t>
+            </a:r>
+          </a:p>
+          <a:p xmlns:a="http://schemas.openxmlformats.org/drawingml/2006/main">
+            <a:r>
+              <a:t>强调这是通过 BAI 统一入口使用模型能力，不代表 OpenAI 或 Anthropic 的官方合作或背书，也不改变相关服务限制。</a:t>
             </a:r>
           </a:p>
         </p:txBody>
@@ -2117,7 +2134,7 @@
   </p:cSld>
   <p:clrMap bg1="lt1" tx1="dk1" bg2="lt2" tx2="dk2" accent1="accent1" accent2="accent2" accent3="accent3" accent4="accent4" accent5="accent5" accent6="accent6" hlink="hlink" folHlink="folHlink"/>
   <p:sldLayoutIdLst>
-    <p:sldLayoutId xmlns:r="http://schemas.openxmlformats.org/officeDocument/2006/relationships" id="2147483649" r:id="R14168b18945f4e29"/>
+    <p:sldLayoutId xmlns:r="http://schemas.openxmlformats.org/officeDocument/2006/relationships" id="2147483649" r:id="R9ae818c7812846ef"/>
   </p:sldLayoutIdLst>
   <p:hf sldNum="0" hdr="0" ftr="0" dt="0"/>
   <p:txStyles>
@@ -2760,7 +2777,7 @@
           <p:nvPr/>
         </p:nvPicPr>
         <p:blipFill>
-          <a:blip xmlns:r="http://schemas.openxmlformats.org/officeDocument/2006/relationships" xmlns:a="http://schemas.openxmlformats.org/drawingml/2006/main" r:embed="R85dbab4045544d19"/>
+          <a:blip xmlns:r="http://schemas.openxmlformats.org/officeDocument/2006/relationships" xmlns:a="http://schemas.openxmlformats.org/drawingml/2006/main" r:embed="Rcf42cfc1008a477b"/>
           <a:stretch xmlns:a="http://schemas.openxmlformats.org/drawingml/2006/main">
             <a:fillRect l="0" t="0" r="0" b="0"/>
           </a:stretch>
@@ -2944,7 +2961,7 @@
           <p:nvPr/>
         </p:nvPicPr>
         <p:blipFill>
-          <a:blip xmlns:r="http://schemas.openxmlformats.org/officeDocument/2006/relationships" xmlns:a="http://schemas.openxmlformats.org/drawingml/2006/main" r:embed="R62afd280445c4303"/>
+          <a:blip xmlns:r="http://schemas.openxmlformats.org/officeDocument/2006/relationships" xmlns:a="http://schemas.openxmlformats.org/drawingml/2006/main" r:embed="Rc2373ba72bd642a0"/>
           <a:stretch xmlns:a="http://schemas.openxmlformats.org/drawingml/2006/main">
             <a:fillRect l="0" t="0" r="0" b="0"/>
           </a:stretch>
@@ -14176,7 +14193,7 @@
         </p:spPr>
         <p:txBody>
           <a:bodyPr xmlns:a="http://schemas.openxmlformats.org/drawingml/2006/main" wrap="square" lIns="0" tIns="0" rIns="0" bIns="0" anchor="ctr">
-            <a:normAutofit/>
+            <a:normAutofit fontScale="100000"/>
           </a:bodyPr>
           <a:lstStyle xmlns:a="http://schemas.openxmlformats.org/drawingml/2006/main"/>
           <a:p xmlns:a="http://schemas.openxmlformats.org/drawingml/2006/main">
@@ -14192,7 +14209,7 @@
                 <a:ea typeface="Aptos"/>
                 <a:cs typeface="Aptos"/>
               </a:rPr>
-              <a:t>TARGET USERS</a:t>
+              <a:t>LOCAL USER VALUE</a:t>
             </a:r>
           </a:p>
         </p:txBody>
@@ -14223,7 +14240,7 @@
         </p:spPr>
         <p:txBody>
           <a:bodyPr xmlns:a="http://schemas.openxmlformats.org/drawingml/2006/main" wrap="square" lIns="0" tIns="0" rIns="0" bIns="0" anchor="ctr">
-            <a:normAutofit/>
+            <a:normAutofit fontScale="100000"/>
           </a:bodyPr>
           <a:lstStyle xmlns:a="http://schemas.openxmlformats.org/drawingml/2006/main"/>
           <a:p xmlns:a="http://schemas.openxmlformats.org/drawingml/2006/main">
@@ -14239,7 +14256,7 @@
                 <a:ea typeface="PingFang SC"/>
                 <a:cs typeface="PingFang SC"/>
               </a:rPr>
-              <a:t>目标用户：先占领高频、长链路的项目工作</a:t>
+              <a:t>本地化优势：普通用户也能用优质模型完成真实任务</a:t>
             </a:r>
           </a:p>
         </p:txBody>
@@ -14305,7 +14322,7 @@
         </p:spPr>
         <p:txBody>
           <a:bodyPr xmlns:a="http://schemas.openxmlformats.org/drawingml/2006/main" wrap="square" lIns="0" tIns="0" rIns="0" bIns="0" anchor="ctr">
-            <a:normAutofit/>
+            <a:normAutofit fontScale="100000"/>
           </a:bodyPr>
           <a:lstStyle xmlns:a="http://schemas.openxmlformats.org/drawingml/2006/main"/>
           <a:p xmlns:a="http://schemas.openxmlformats.org/drawingml/2006/main">
@@ -14321,7 +14338,7 @@
                 <a:ea typeface="PingFang SC"/>
                 <a:cs typeface="PingFang SC"/>
               </a:rPr>
-              <a:t>市场切入</a:t>
+              <a:t>用户价值</a:t>
             </a:r>
           </a:p>
         </p:txBody>
@@ -14465,7 +14482,7 @@
         </p:spPr>
         <p:txBody>
           <a:bodyPr xmlns:a="http://schemas.openxmlformats.org/drawingml/2006/main" wrap="square" lIns="0" tIns="0" rIns="0" bIns="0" anchor="t">
-            <a:normAutofit/>
+            <a:normAutofit fontScale="100000"/>
           </a:bodyPr>
           <a:lstStyle xmlns:a="http://schemas.openxmlformats.org/drawingml/2006/main"/>
           <a:p xmlns:a="http://schemas.openxmlformats.org/drawingml/2006/main">
@@ -14481,7 +14498,7 @@
                 <a:ea typeface="PingFang SC"/>
                 <a:cs typeface="PingFang SC"/>
               </a:rPr>
-              <a:t>个人开发者 / 研究者</a:t>
+              <a:t>从聊天到交付</a:t>
             </a:r>
           </a:p>
         </p:txBody>
@@ -14559,7 +14576,7 @@
         </p:spPr>
         <p:txBody>
           <a:bodyPr xmlns:a="http://schemas.openxmlformats.org/drawingml/2006/main" wrap="square" lIns="0" tIns="0" rIns="0" bIns="0" anchor="t">
-            <a:normAutofit/>
+            <a:normAutofit fontScale="100000"/>
           </a:bodyPr>
           <a:lstStyle xmlns:a="http://schemas.openxmlformats.org/drawingml/2006/main"/>
           <a:p xmlns:a="http://schemas.openxmlformats.org/drawingml/2006/main">
@@ -14575,7 +14592,7 @@
                 <a:ea typeface="PingFang SC"/>
                 <a:cs typeface="PingFang SC"/>
               </a:rPr>
-              <a:t>本地项目任务长、文件多、上下文重复传递。</a:t>
+              <a:t>不少 AI 使用仍停在问答，长任务难以持续推进。</a:t>
             </a:r>
           </a:p>
         </p:txBody>
@@ -14653,7 +14670,7 @@
         </p:spPr>
         <p:txBody>
           <a:bodyPr xmlns:a="http://schemas.openxmlformats.org/drawingml/2006/main" wrap="square" lIns="0" tIns="0" rIns="0" bIns="0" anchor="t">
-            <a:normAutofit/>
+            <a:normAutofit fontScale="100000"/>
           </a:bodyPr>
           <a:lstStyle xmlns:a="http://schemas.openxmlformats.org/drawingml/2006/main"/>
           <a:p xmlns:a="http://schemas.openxmlformats.org/drawingml/2006/main">
@@ -14669,7 +14686,7 @@
                 <a:ea typeface="PingFang SC"/>
                 <a:cs typeface="PingFang SC"/>
               </a:rPr>
-              <a:t>从问题到代码、文档和图表的一站式交付。</a:t>
+              <a:t>任务过程进入同一工作面，直接交付可用成果。</a:t>
             </a:r>
           </a:p>
         </p:txBody>
@@ -14782,7 +14799,7 @@
         </p:spPr>
         <p:txBody>
           <a:bodyPr xmlns:a="http://schemas.openxmlformats.org/drawingml/2006/main" wrap="square" lIns="0" tIns="0" rIns="0" bIns="0" anchor="t">
-            <a:normAutofit/>
+            <a:normAutofit fontScale="100000"/>
           </a:bodyPr>
           <a:lstStyle xmlns:a="http://schemas.openxmlformats.org/drawingml/2006/main"/>
           <a:p xmlns:a="http://schemas.openxmlformats.org/drawingml/2006/main">
@@ -14798,7 +14815,7 @@
                 <a:ea typeface="PingFang SC"/>
                 <a:cs typeface="PingFang SC"/>
               </a:rPr>
-              <a:t>小型研发团队</a:t>
+              <a:t>统一模型入口</a:t>
             </a:r>
           </a:p>
         </p:txBody>
@@ -14876,7 +14893,7 @@
         </p:spPr>
         <p:txBody>
           <a:bodyPr xmlns:a="http://schemas.openxmlformats.org/drawingml/2006/main" wrap="square" lIns="0" tIns="0" rIns="0" bIns="0" anchor="t">
-            <a:normAutofit/>
+            <a:normAutofit fontScale="100000"/>
           </a:bodyPr>
           <a:lstStyle xmlns:a="http://schemas.openxmlformats.org/drawingml/2006/main"/>
           <a:p xmlns:a="http://schemas.openxmlformats.org/drawingml/2006/main">
@@ -14892,7 +14909,7 @@
                 <a:ea typeface="PingFang SC"/>
                 <a:cs typeface="PingFang SC"/>
               </a:rPr>
-              <a:t>流程难复用，Agent 行为和权限口径难统一。</a:t>
+              <a:t>配置、探测和选模型门槛高，普通用户难以稳定使用。</a:t>
             </a:r>
           </a:p>
         </p:txBody>
@@ -14970,7 +14987,7 @@
         </p:spPr>
         <p:txBody>
           <a:bodyPr xmlns:a="http://schemas.openxmlformats.org/drawingml/2006/main" wrap="square" lIns="0" tIns="0" rIns="0" bIns="0" anchor="t">
-            <a:normAutofit/>
+            <a:normAutofit fontScale="100000"/>
           </a:bodyPr>
           <a:lstStyle xmlns:a="http://schemas.openxmlformats.org/drawingml/2006/main"/>
           <a:p xmlns:a="http://schemas.openxmlformats.org/drawingml/2006/main">
@@ -14986,7 +15003,7 @@
                 <a:ea typeface="PingFang SC"/>
                 <a:cs typeface="PingFang SC"/>
               </a:rPr>
-              <a:t>共享技能、规则、服务配置与审阅标准。</a:t>
+              <a:t>BAI 统一入口：Claude、GPT 等模型即配即用。</a:t>
             </a:r>
           </a:p>
         </p:txBody>
@@ -15099,7 +15116,7 @@
         </p:spPr>
         <p:txBody>
           <a:bodyPr xmlns:a="http://schemas.openxmlformats.org/drawingml/2006/main" wrap="square" lIns="0" tIns="0" rIns="0" bIns="0" anchor="t">
-            <a:normAutofit/>
+            <a:normAutofit fontScale="100000"/>
           </a:bodyPr>
           <a:lstStyle xmlns:a="http://schemas.openxmlformats.org/drawingml/2006/main"/>
           <a:p xmlns:a="http://schemas.openxmlformats.org/drawingml/2006/main">
@@ -15115,7 +15132,7 @@
                 <a:ea typeface="PingFang SC"/>
                 <a:cs typeface="PingFang SC"/>
               </a:rPr>
-              <a:t>BAI 生态用户</a:t>
+              <a:t>普通用户也能完成</a:t>
             </a:r>
           </a:p>
         </p:txBody>
@@ -15193,7 +15210,7 @@
         </p:spPr>
         <p:txBody>
           <a:bodyPr xmlns:a="http://schemas.openxmlformats.org/drawingml/2006/main" wrap="square" lIns="0" tIns="0" rIns="0" bIns="0" anchor="t">
-            <a:normAutofit/>
+            <a:normAutofit fontScale="100000"/>
           </a:bodyPr>
           <a:lstStyle xmlns:a="http://schemas.openxmlformats.org/drawingml/2006/main"/>
           <a:p xmlns:a="http://schemas.openxmlformats.org/drawingml/2006/main">
@@ -15209,7 +15226,7 @@
                 <a:ea typeface="PingFang SC"/>
                 <a:cs typeface="PingFang SC"/>
               </a:rPr>
-              <a:t>底层执行能力缺少持续桌面入口与产物工作面。</a:t>
+              <a:t>非开发者更依赖默认可用、过程清晰的产品路径。</a:t>
             </a:r>
           </a:p>
         </p:txBody>
@@ -15287,7 +15304,7 @@
         </p:spPr>
         <p:txBody>
           <a:bodyPr xmlns:a="http://schemas.openxmlformats.org/drawingml/2006/main" wrap="square" lIns="0" tIns="0" rIns="0" bIns="0" anchor="t">
-            <a:normAutofit/>
+            <a:normAutofit fontScale="100000"/>
           </a:bodyPr>
           <a:lstStyle xmlns:a="http://schemas.openxmlformats.org/drawingml/2006/main"/>
           <a:p xmlns:a="http://schemas.openxmlformats.org/drawingml/2006/main">
@@ -15303,7 +15320,7 @@
                 <a:ea typeface="PingFang SC"/>
                 <a:cs typeface="PingFang SC"/>
               </a:rPr>
-              <a:t>模型、运行时与生态能力进入日常项目流程。</a:t>
+              <a:t>配置极简、过程可见，最终获得可验证产物。</a:t>
             </a:r>
           </a:p>
         </p:txBody>
@@ -15334,7 +15351,7 @@
         </p:spPr>
         <p:txBody>
           <a:bodyPr xmlns:a="http://schemas.openxmlformats.org/drawingml/2006/main" wrap="square" lIns="0" tIns="0" rIns="0" bIns="0" anchor="ctr">
-            <a:normAutofit/>
+            <a:normAutofit fontScale="100000"/>
           </a:bodyPr>
           <a:lstStyle xmlns:a="http://schemas.openxmlformats.org/drawingml/2006/main"/>
           <a:p xmlns:a="http://schemas.openxmlformats.org/drawingml/2006/main">
@@ -15350,7 +15367,7 @@
                 <a:ea typeface="PingFang SC"/>
                 <a:cs typeface="PingFang SC"/>
               </a:rPr>
-              <a:t>首批验证不追求覆盖所有 AI 用户，而聚焦已有本地项目、愿意把完整任务交给 Agent 的用户。</a:t>
+              <a:t>不是把聊天窗口搬到桌面，而是把优质模型变成普通用户能完成任务的工作台。</a:t>
             </a:r>
           </a:p>
         </p:txBody>
@@ -15381,7 +15398,7 @@
         </p:spPr>
         <p:txBody>
           <a:bodyPr xmlns:a="http://schemas.openxmlformats.org/drawingml/2006/main" wrap="square" lIns="0" tIns="0" rIns="0" bIns="0" anchor="ctr">
-            <a:normAutofit/>
+            <a:normAutofit fontScale="100000"/>
           </a:bodyPr>
           <a:lstStyle xmlns:a="http://schemas.openxmlformats.org/drawingml/2006/main"/>
           <a:p xmlns:a="http://schemas.openxmlformats.org/drawingml/2006/main">
@@ -15397,7 +15414,7 @@
                 <a:ea typeface="Aptos"/>
                 <a:cs typeface="Aptos"/>
               </a:rPr>
-              <a:t>市场判断基于 Jobs-to-be-Done；不使用未经验证的市场规模数字</a:t>
+              <a:t>产品判断基于 Jobs-to-be-Done；模型服务以用户授权与实际可用性为准</a:t>
             </a:r>
           </a:p>
         </p:txBody>
@@ -18801,7 +18818,7 @@
           <p:nvPr/>
         </p:nvPicPr>
         <p:blipFill>
-          <a:blip xmlns:r="http://schemas.openxmlformats.org/officeDocument/2006/relationships" xmlns:a="http://schemas.openxmlformats.org/drawingml/2006/main" r:embed="Rd2a14afea1ff4908"/>
+          <a:blip xmlns:r="http://schemas.openxmlformats.org/officeDocument/2006/relationships" xmlns:a="http://schemas.openxmlformats.org/drawingml/2006/main" r:embed="R26ed591291b6440d"/>
           <a:stretch xmlns:a="http://schemas.openxmlformats.org/drawingml/2006/main">
             <a:fillRect l="0" t="0" r="0" b="0"/>
           </a:stretch>
@@ -23113,7 +23130,7 @@
           <p:nvPr/>
         </p:nvPicPr>
         <p:blipFill>
-          <a:blip xmlns:r="http://schemas.openxmlformats.org/officeDocument/2006/relationships" xmlns:a="http://schemas.openxmlformats.org/drawingml/2006/main" r:embed="R25b0caefd9cb475d"/>
+          <a:blip xmlns:r="http://schemas.openxmlformats.org/officeDocument/2006/relationships" xmlns:a="http://schemas.openxmlformats.org/drawingml/2006/main" r:embed="R77eaa1ec5db7486b"/>
           <a:stretch xmlns:a="http://schemas.openxmlformats.org/drawingml/2006/main">
             <a:fillRect l="0" t="0" r="0" b="0"/>
           </a:stretch>

</xml_diff>

<commit_message>
docs: remove slide evidence footers
</commit_message>
<xml_diff>
--- a/docs/presentation/BAI-Work-Defense-Deck.pptx
+++ b/docs/presentation/BAI-Work-Defense-Deck.pptx
@@ -2,31 +2,31 @@
 <file path=ppt/presentation.xml><?xml version="1.0" encoding="utf-8"?>
 <p:presentation xmlns:p="http://schemas.openxmlformats.org/presentationml/2006/main">
   <p:sldMasterIdLst>
-    <p:sldMasterId xmlns:r="http://schemas.openxmlformats.org/officeDocument/2006/relationships" id="2147483648" r:id="R1a812313b94645f9"/>
+    <p:sldMasterId xmlns:r="http://schemas.openxmlformats.org/officeDocument/2006/relationships" id="2147483648" r:id="R7fab43f5caa14b91"/>
   </p:sldMasterIdLst>
   <p:notesMasterIdLst>
-    <p:notesMasterId xmlns:r="http://schemas.openxmlformats.org/officeDocument/2006/relationships" r:id="R7c62846fe3d841f3"/>
+    <p:notesMasterId xmlns:r="http://schemas.openxmlformats.org/officeDocument/2006/relationships" r:id="Rbb9fbd8b66d94dd2"/>
   </p:notesMasterIdLst>
   <p:sldIdLst>
-    <p:sldId xmlns:r="http://schemas.openxmlformats.org/officeDocument/2006/relationships" id="256" r:id="Rb53195806adf446c"/>
-    <p:sldId xmlns:r="http://schemas.openxmlformats.org/officeDocument/2006/relationships" id="257" r:id="Rfb156c62d59d4c50"/>
-    <p:sldId xmlns:r="http://schemas.openxmlformats.org/officeDocument/2006/relationships" id="258" r:id="Rdcb7060b842b4b30"/>
-    <p:sldId xmlns:r="http://schemas.openxmlformats.org/officeDocument/2006/relationships" id="259" r:id="Rfe7c3555b664477c"/>
-    <p:sldId xmlns:r="http://schemas.openxmlformats.org/officeDocument/2006/relationships" id="260" r:id="Rac5c5cdc7c6e4024"/>
-    <p:sldId xmlns:r="http://schemas.openxmlformats.org/officeDocument/2006/relationships" id="261" r:id="Rc1a95a62ed204b48"/>
-    <p:sldId xmlns:r="http://schemas.openxmlformats.org/officeDocument/2006/relationships" id="262" r:id="Ra37fc7dcbc6149de"/>
-    <p:sldId xmlns:r="http://schemas.openxmlformats.org/officeDocument/2006/relationships" id="263" r:id="R5c8fa9984c764dcb"/>
-    <p:sldId xmlns:r="http://schemas.openxmlformats.org/officeDocument/2006/relationships" id="264" r:id="R187021781aa64d61"/>
-    <p:sldId xmlns:r="http://schemas.openxmlformats.org/officeDocument/2006/relationships" id="265" r:id="R96b7b273acbd4770"/>
-    <p:sldId xmlns:r="http://schemas.openxmlformats.org/officeDocument/2006/relationships" id="266" r:id="R3b3cb4782a414c14"/>
-    <p:sldId xmlns:r="http://schemas.openxmlformats.org/officeDocument/2006/relationships" id="267" r:id="R15f3a89f494f4623"/>
-    <p:sldId xmlns:r="http://schemas.openxmlformats.org/officeDocument/2006/relationships" id="268" r:id="Ra420fcf5042e42c5"/>
-    <p:sldId xmlns:r="http://schemas.openxmlformats.org/officeDocument/2006/relationships" id="269" r:id="Rb18f842ec1784f14"/>
-    <p:sldId xmlns:r="http://schemas.openxmlformats.org/officeDocument/2006/relationships" id="270" r:id="R762a670a5186416f"/>
-    <p:sldId xmlns:r="http://schemas.openxmlformats.org/officeDocument/2006/relationships" id="271" r:id="Rd76e192d7ee44017"/>
-    <p:sldId xmlns:r="http://schemas.openxmlformats.org/officeDocument/2006/relationships" id="272" r:id="Rc7152f22fded4656"/>
-    <p:sldId xmlns:r="http://schemas.openxmlformats.org/officeDocument/2006/relationships" id="273" r:id="Rdf12a285e5b944cf"/>
-    <p:sldId xmlns:r="http://schemas.openxmlformats.org/officeDocument/2006/relationships" id="274" r:id="R3bf5e05478064114"/>
+    <p:sldId xmlns:r="http://schemas.openxmlformats.org/officeDocument/2006/relationships" id="256" r:id="R88a4528b3ab64885"/>
+    <p:sldId xmlns:r="http://schemas.openxmlformats.org/officeDocument/2006/relationships" id="257" r:id="Rf38eb84d07c44586"/>
+    <p:sldId xmlns:r="http://schemas.openxmlformats.org/officeDocument/2006/relationships" id="258" r:id="R05f665cd009a434b"/>
+    <p:sldId xmlns:r="http://schemas.openxmlformats.org/officeDocument/2006/relationships" id="259" r:id="Re5a5ed117be24032"/>
+    <p:sldId xmlns:r="http://schemas.openxmlformats.org/officeDocument/2006/relationships" id="260" r:id="Rf5cbb0b38fdf4f7c"/>
+    <p:sldId xmlns:r="http://schemas.openxmlformats.org/officeDocument/2006/relationships" id="261" r:id="R6ccdc5e499e64adb"/>
+    <p:sldId xmlns:r="http://schemas.openxmlformats.org/officeDocument/2006/relationships" id="262" r:id="R1bd9c53c4abd4f1d"/>
+    <p:sldId xmlns:r="http://schemas.openxmlformats.org/officeDocument/2006/relationships" id="263" r:id="Ra056053b63344032"/>
+    <p:sldId xmlns:r="http://schemas.openxmlformats.org/officeDocument/2006/relationships" id="264" r:id="R7d49ee1a5c814cfd"/>
+    <p:sldId xmlns:r="http://schemas.openxmlformats.org/officeDocument/2006/relationships" id="265" r:id="Ra9b72f973fab4250"/>
+    <p:sldId xmlns:r="http://schemas.openxmlformats.org/officeDocument/2006/relationships" id="266" r:id="R370d09b547a14b42"/>
+    <p:sldId xmlns:r="http://schemas.openxmlformats.org/officeDocument/2006/relationships" id="267" r:id="R598492fbb91140dc"/>
+    <p:sldId xmlns:r="http://schemas.openxmlformats.org/officeDocument/2006/relationships" id="268" r:id="R06af79e31ba9459e"/>
+    <p:sldId xmlns:r="http://schemas.openxmlformats.org/officeDocument/2006/relationships" id="269" r:id="Ra563fd9a18754608"/>
+    <p:sldId xmlns:r="http://schemas.openxmlformats.org/officeDocument/2006/relationships" id="270" r:id="R8fb042ac888e4866"/>
+    <p:sldId xmlns:r="http://schemas.openxmlformats.org/officeDocument/2006/relationships" id="271" r:id="R3fdcc68542a748c0"/>
+    <p:sldId xmlns:r="http://schemas.openxmlformats.org/officeDocument/2006/relationships" id="272" r:id="Ra0dc3f2c3ea144bd"/>
+    <p:sldId xmlns:r="http://schemas.openxmlformats.org/officeDocument/2006/relationships" id="273" r:id="R5fdbc260b21544f0"/>
+    <p:sldId xmlns:r="http://schemas.openxmlformats.org/officeDocument/2006/relationships" id="274" r:id="Ra7ccdd15ca2446b5"/>
   </p:sldIdLst>
   <p:sldSz cx="12191695" cy="6858000"/>
   <p:notesSz cx="6858000" cy="9144000"/>
@@ -2134,7 +2134,7 @@
   </p:cSld>
   <p:clrMap bg1="lt1" tx1="dk1" bg2="lt2" tx2="dk2" accent1="accent1" accent2="accent2" accent3="accent3" accent4="accent4" accent5="accent5" accent6="accent6" hlink="hlink" folHlink="folHlink"/>
   <p:sldLayoutIdLst>
-    <p:sldLayoutId xmlns:r="http://schemas.openxmlformats.org/officeDocument/2006/relationships" id="2147483649" r:id="R9ae818c7812846ef"/>
+    <p:sldLayoutId xmlns:r="http://schemas.openxmlformats.org/officeDocument/2006/relationships" id="2147483649" r:id="Rfbb19dc3d0384c4f"/>
   </p:sldLayoutIdLst>
   <p:hf sldNum="0" hdr="0" ftr="0" dt="0"/>
   <p:txStyles>
@@ -2777,7 +2777,7 @@
           <p:nvPr/>
         </p:nvPicPr>
         <p:blipFill>
-          <a:blip xmlns:r="http://schemas.openxmlformats.org/officeDocument/2006/relationships" xmlns:a="http://schemas.openxmlformats.org/drawingml/2006/main" r:embed="Rcf42cfc1008a477b"/>
+          <a:blip xmlns:r="http://schemas.openxmlformats.org/officeDocument/2006/relationships" xmlns:a="http://schemas.openxmlformats.org/drawingml/2006/main" r:embed="R561b9b6cbdea4018"/>
           <a:stretch xmlns:a="http://schemas.openxmlformats.org/drawingml/2006/main">
             <a:fillRect l="0" t="0" r="0" b="0"/>
           </a:stretch>
@@ -2961,7 +2961,7 @@
           <p:nvPr/>
         </p:nvPicPr>
         <p:blipFill>
-          <a:blip xmlns:r="http://schemas.openxmlformats.org/officeDocument/2006/relationships" xmlns:a="http://schemas.openxmlformats.org/drawingml/2006/main" r:embed="Rc2373ba72bd642a0"/>
+          <a:blip xmlns:r="http://schemas.openxmlformats.org/officeDocument/2006/relationships" xmlns:a="http://schemas.openxmlformats.org/drawingml/2006/main" r:embed="Rf56da05e1564486a"/>
           <a:stretch xmlns:a="http://schemas.openxmlformats.org/drawingml/2006/main">
             <a:fillRect l="0" t="0" r="0" b="0"/>
           </a:stretch>
@@ -4856,53 +4856,6 @@
       </p:sp>
       <p:sp>
         <p:nvSpPr>
-          <p:cNvPr id="30" name="Text 28">
-            <a:extLst xmlns:a="http://schemas.openxmlformats.org/drawingml/2006/main">
-              <a:ext uri="{FF2B5EF4-FFF2-40B4-BE49-F238E27FC236}">
-                <a16:creationId xmlns:a16="http://schemas.microsoft.com/office/drawing/2014/main" id="{FF6585DD-B4A6-4623-A2C1-2F386A97DF95}"/>
-              </a:ext>
-            </a:extLst>
-          </p:cNvPr>
-          <p:cNvSpPr>
-            <a:spLocks xmlns:a="http://schemas.openxmlformats.org/drawingml/2006/main" noGrp="1"/>
-          </p:cNvSpPr>
-          <p:nvPr/>
-        </p:nvSpPr>
-        <p:spPr>
-          <a:xfrm xmlns:a="http://schemas.openxmlformats.org/drawingml/2006/main">
-            <a:off x="530352" y="6547104"/>
-            <a:ext cx="9052560" cy="164592"/>
-          </a:xfrm>
-          <a:prstGeom xmlns:a="http://schemas.openxmlformats.org/drawingml/2006/main" prst="rect">
-            <a:avLst/>
-          </a:prstGeom>
-          <a:noFill xmlns:a="http://schemas.openxmlformats.org/drawingml/2006/main"/>
-        </p:spPr>
-        <p:txBody>
-          <a:bodyPr xmlns:a="http://schemas.openxmlformats.org/drawingml/2006/main" wrap="square" lIns="0" tIns="0" rIns="0" bIns="0" anchor="ctr">
-            <a:normAutofit fontScale="100000"/>
-          </a:bodyPr>
-          <a:lstStyle xmlns:a="http://schemas.openxmlformats.org/drawingml/2006/main"/>
-          <a:p xmlns:a="http://schemas.openxmlformats.org/drawingml/2006/main">
-            <a:pPr marL="0" indent="0" algn="l">
-              <a:buNone/>
-            </a:pPr>
-            <a:r>
-              <a:rPr sz="830">
-                <a:solidFill>
-                  <a:srgbClr val="69727E"/>
-                </a:solidFill>
-                <a:latin typeface="Aptos"/>
-                <a:ea typeface="Aptos"/>
-                <a:cs typeface="Aptos"/>
-              </a:rPr>
-              <a:t>实现证据：history hygiene defaults · compaction settings · validation bounds</a:t>
-            </a:r>
-          </a:p>
-        </p:txBody>
-      </p:sp>
-      <p:sp>
-        <p:nvSpPr>
           <p:cNvPr id="31" name="Text 29">
             <a:extLst xmlns:a="http://schemas.openxmlformats.org/drawingml/2006/main">
               <a:ext uri="{FF2B5EF4-FFF2-40B4-BE49-F238E27FC236}">
@@ -6602,53 +6555,6 @@
       </p:sp>
       <p:sp>
         <p:nvSpPr>
-          <p:cNvPr id="42" name="Text 40">
-            <a:extLst xmlns:a="http://schemas.openxmlformats.org/drawingml/2006/main">
-              <a:ext uri="{FF2B5EF4-FFF2-40B4-BE49-F238E27FC236}">
-                <a16:creationId xmlns:a16="http://schemas.microsoft.com/office/drawing/2014/main" id="{313D2E2A-2E9A-4BC6-BF5D-1633480678C7}"/>
-              </a:ext>
-            </a:extLst>
-          </p:cNvPr>
-          <p:cNvSpPr>
-            <a:spLocks xmlns:a="http://schemas.openxmlformats.org/drawingml/2006/main" noGrp="1"/>
-          </p:cNvSpPr>
-          <p:nvPr/>
-        </p:nvSpPr>
-        <p:spPr>
-          <a:xfrm xmlns:a="http://schemas.openxmlformats.org/drawingml/2006/main">
-            <a:off x="530352" y="6547104"/>
-            <a:ext cx="9052560" cy="164592"/>
-          </a:xfrm>
-          <a:prstGeom xmlns:a="http://schemas.openxmlformats.org/drawingml/2006/main" prst="rect">
-            <a:avLst/>
-          </a:prstGeom>
-          <a:noFill xmlns:a="http://schemas.openxmlformats.org/drawingml/2006/main"/>
-        </p:spPr>
-        <p:txBody>
-          <a:bodyPr xmlns:a="http://schemas.openxmlformats.org/drawingml/2006/main" wrap="square" lIns="0" tIns="0" rIns="0" bIns="0" anchor="ctr">
-            <a:normAutofit fontScale="100000"/>
-          </a:bodyPr>
-          <a:lstStyle xmlns:a="http://schemas.openxmlformats.org/drawingml/2006/main"/>
-          <a:p xmlns:a="http://schemas.openxmlformats.org/drawingml/2006/main">
-            <a:pPr marL="0" indent="0" algn="l">
-              <a:buNone/>
-            </a:pPr>
-            <a:r>
-              <a:rPr sz="830">
-                <a:solidFill>
-                  <a:srgbClr val="69727E"/>
-                </a:solidFill>
-                <a:latin typeface="Aptos"/>
-                <a:ea typeface="Aptos"/>
-                <a:cs typeface="Aptos"/>
-              </a:rPr>
-              <a:t>实现证据：runtime instruction loader · component install tests · hook manifest guard</a:t>
-            </a:r>
-          </a:p>
-        </p:txBody>
-      </p:sp>
-      <p:sp>
-        <p:nvSpPr>
           <p:cNvPr id="43" name="Text 41">
             <a:extLst xmlns:a="http://schemas.openxmlformats.org/drawingml/2006/main">
               <a:ext uri="{FF2B5EF4-FFF2-40B4-BE49-F238E27FC236}">
@@ -8578,53 +8484,6 @@
       </p:sp>
       <p:sp>
         <p:nvSpPr>
-          <p:cNvPr id="47" name="Text 45">
-            <a:extLst xmlns:a="http://schemas.openxmlformats.org/drawingml/2006/main">
-              <a:ext uri="{FF2B5EF4-FFF2-40B4-BE49-F238E27FC236}">
-                <a16:creationId xmlns:a16="http://schemas.microsoft.com/office/drawing/2014/main" id="{4821D10E-DCCD-421D-A233-9156F66BF2C6}"/>
-              </a:ext>
-            </a:extLst>
-          </p:cNvPr>
-          <p:cNvSpPr>
-            <a:spLocks xmlns:a="http://schemas.openxmlformats.org/drawingml/2006/main" noGrp="1"/>
-          </p:cNvSpPr>
-          <p:nvPr/>
-        </p:nvSpPr>
-        <p:spPr>
-          <a:xfrm xmlns:a="http://schemas.openxmlformats.org/drawingml/2006/main">
-            <a:off x="530352" y="6547104"/>
-            <a:ext cx="9052560" cy="164592"/>
-          </a:xfrm>
-          <a:prstGeom xmlns:a="http://schemas.openxmlformats.org/drawingml/2006/main" prst="rect">
-            <a:avLst/>
-          </a:prstGeom>
-          <a:noFill xmlns:a="http://schemas.openxmlformats.org/drawingml/2006/main"/>
-        </p:spPr>
-        <p:txBody>
-          <a:bodyPr xmlns:a="http://schemas.openxmlformats.org/drawingml/2006/main" wrap="square" lIns="0" tIns="0" rIns="0" bIns="0" anchor="ctr">
-            <a:normAutofit fontScale="100000"/>
-          </a:bodyPr>
-          <a:lstStyle xmlns:a="http://schemas.openxmlformats.org/drawingml/2006/main"/>
-          <a:p xmlns:a="http://schemas.openxmlformats.org/drawingml/2006/main">
-            <a:pPr marL="0" indent="0" algn="l">
-              <a:buNone/>
-            </a:pPr>
-            <a:r>
-              <a:rPr sz="830">
-                <a:solidFill>
-                  <a:srgbClr val="69727E"/>
-                </a:solidFill>
-                <a:latin typeface="Aptos"/>
-                <a:ea typeface="Aptos"/>
-                <a:cs typeface="Aptos"/>
-              </a:rPr>
-              <a:t>交付原则：产品能力与当前可执行状态分开陈述；未开放能力不冒充为已生效</a:t>
-            </a:r>
-          </a:p>
-        </p:txBody>
-      </p:sp>
-      <p:sp>
-        <p:nvSpPr>
           <p:cNvPr id="48" name="Text 46">
             <a:extLst xmlns:a="http://schemas.openxmlformats.org/drawingml/2006/main">
               <a:ext uri="{FF2B5EF4-FFF2-40B4-BE49-F238E27FC236}">
@@ -10231,53 +10090,6 @@
       </p:sp>
       <p:sp>
         <p:nvSpPr>
-          <p:cNvPr id="40" name="Text 38">
-            <a:extLst xmlns:a="http://schemas.openxmlformats.org/drawingml/2006/main">
-              <a:ext uri="{FF2B5EF4-FFF2-40B4-BE49-F238E27FC236}">
-                <a16:creationId xmlns:a16="http://schemas.microsoft.com/office/drawing/2014/main" id="{392A811F-8C60-4919-945A-D9E9DCDC50FD}"/>
-              </a:ext>
-            </a:extLst>
-          </p:cNvPr>
-          <p:cNvSpPr>
-            <a:spLocks xmlns:a="http://schemas.openxmlformats.org/drawingml/2006/main" noGrp="1"/>
-          </p:cNvSpPr>
-          <p:nvPr/>
-        </p:nvSpPr>
-        <p:spPr>
-          <a:xfrm xmlns:a="http://schemas.openxmlformats.org/drawingml/2006/main">
-            <a:off x="530352" y="6547104"/>
-            <a:ext cx="9052560" cy="164592"/>
-          </a:xfrm>
-          <a:prstGeom xmlns:a="http://schemas.openxmlformats.org/drawingml/2006/main" prst="rect">
-            <a:avLst/>
-          </a:prstGeom>
-          <a:noFill xmlns:a="http://schemas.openxmlformats.org/drawingml/2006/main"/>
-        </p:spPr>
-        <p:txBody>
-          <a:bodyPr xmlns:a="http://schemas.openxmlformats.org/drawingml/2006/main" wrap="square" lIns="0" tIns="0" rIns="0" bIns="0" anchor="ctr">
-            <a:normAutofit/>
-          </a:bodyPr>
-          <a:lstStyle xmlns:a="http://schemas.openxmlformats.org/drawingml/2006/main"/>
-          <a:p xmlns:a="http://schemas.openxmlformats.org/drawingml/2006/main">
-            <a:pPr marL="0" indent="0" algn="l">
-              <a:buNone/>
-            </a:pPr>
-            <a:r>
-              <a:rPr sz="830">
-                <a:solidFill>
-                  <a:srgbClr val="69727E"/>
-                </a:solidFill>
-                <a:latin typeface="Aptos"/>
-                <a:ea typeface="Aptos"/>
-                <a:cs typeface="Aptos"/>
-              </a:rPr>
-              <a:t>AI 的价值通过任务闭环证明；生态溯源作为未来方向，不包装为当前能力</a:t>
-            </a:r>
-          </a:p>
-        </p:txBody>
-      </p:sp>
-      <p:sp>
-        <p:nvSpPr>
           <p:cNvPr id="41" name="Text 39">
             <a:extLst xmlns:a="http://schemas.openxmlformats.org/drawingml/2006/main">
               <a:ext uri="{FF2B5EF4-FFF2-40B4-BE49-F238E27FC236}">
@@ -12297,53 +12109,6 @@
       </p:sp>
       <p:sp>
         <p:nvSpPr>
-          <p:cNvPr id="47" name="Text 45">
-            <a:extLst xmlns:a="http://schemas.openxmlformats.org/drawingml/2006/main">
-              <a:ext uri="{FF2B5EF4-FFF2-40B4-BE49-F238E27FC236}">
-                <a16:creationId xmlns:a16="http://schemas.microsoft.com/office/drawing/2014/main" id="{E70DE14E-6D9F-4DF1-BB74-DFF46A562662}"/>
-              </a:ext>
-            </a:extLst>
-          </p:cNvPr>
-          <p:cNvSpPr>
-            <a:spLocks xmlns:a="http://schemas.openxmlformats.org/drawingml/2006/main" noGrp="1"/>
-          </p:cNvSpPr>
-          <p:nvPr/>
-        </p:nvSpPr>
-        <p:spPr>
-          <a:xfrm xmlns:a="http://schemas.openxmlformats.org/drawingml/2006/main">
-            <a:off x="530352" y="6547104"/>
-            <a:ext cx="9052560" cy="164592"/>
-          </a:xfrm>
-          <a:prstGeom xmlns:a="http://schemas.openxmlformats.org/drawingml/2006/main" prst="rect">
-            <a:avLst/>
-          </a:prstGeom>
-          <a:noFill xmlns:a="http://schemas.openxmlformats.org/drawingml/2006/main"/>
-        </p:spPr>
-        <p:txBody>
-          <a:bodyPr xmlns:a="http://schemas.openxmlformats.org/drawingml/2006/main" wrap="square" lIns="0" tIns="0" rIns="0" bIns="0" anchor="ctr">
-            <a:normAutofit fontScale="100000"/>
-          </a:bodyPr>
-          <a:lstStyle xmlns:a="http://schemas.openxmlformats.org/drawingml/2006/main"/>
-          <a:p xmlns:a="http://schemas.openxmlformats.org/drawingml/2006/main">
-            <a:pPr marL="0" indent="0" algn="l">
-              <a:buNone/>
-            </a:pPr>
-            <a:r>
-              <a:rPr sz="830">
-                <a:solidFill>
-                  <a:srgbClr val="69727E"/>
-                </a:solidFill>
-                <a:latin typeface="Aptos"/>
-                <a:ea typeface="Aptos"/>
-                <a:cs typeface="Aptos"/>
-              </a:rPr>
-              <a:t>证据来源：BAI Work 当前代码 · 自动化测试 · 构建与运行结果</a:t>
-            </a:r>
-          </a:p>
-        </p:txBody>
-      </p:sp>
-      <p:sp>
-        <p:nvSpPr>
           <p:cNvPr id="48" name="Text 46">
             <a:extLst xmlns:a="http://schemas.openxmlformats.org/drawingml/2006/main">
               <a:ext uri="{FF2B5EF4-FFF2-40B4-BE49-F238E27FC236}">
@@ -14046,53 +13811,6 @@
       </p:sp>
       <p:sp>
         <p:nvSpPr>
-          <p:cNvPr id="40" name="Text 38">
-            <a:extLst xmlns:a="http://schemas.openxmlformats.org/drawingml/2006/main">
-              <a:ext uri="{FF2B5EF4-FFF2-40B4-BE49-F238E27FC236}">
-                <a16:creationId xmlns:a16="http://schemas.microsoft.com/office/drawing/2014/main" id="{97AA1080-03BD-43AB-934E-63A1E114C8F7}"/>
-              </a:ext>
-            </a:extLst>
-          </p:cNvPr>
-          <p:cNvSpPr>
-            <a:spLocks xmlns:a="http://schemas.openxmlformats.org/drawingml/2006/main" noGrp="1"/>
-          </p:cNvSpPr>
-          <p:nvPr/>
-        </p:nvSpPr>
-        <p:spPr>
-          <a:xfrm xmlns:a="http://schemas.openxmlformats.org/drawingml/2006/main">
-            <a:off x="530352" y="6547104"/>
-            <a:ext cx="9052560" cy="164592"/>
-          </a:xfrm>
-          <a:prstGeom xmlns:a="http://schemas.openxmlformats.org/drawingml/2006/main" prst="rect">
-            <a:avLst/>
-          </a:prstGeom>
-          <a:noFill xmlns:a="http://schemas.openxmlformats.org/drawingml/2006/main"/>
-        </p:spPr>
-        <p:txBody>
-          <a:bodyPr xmlns:a="http://schemas.openxmlformats.org/drawingml/2006/main" wrap="square" lIns="0" tIns="0" rIns="0" bIns="0" anchor="ctr">
-            <a:normAutofit fontScale="100000"/>
-          </a:bodyPr>
-          <a:lstStyle xmlns:a="http://schemas.openxmlformats.org/drawingml/2006/main"/>
-          <a:p xmlns:a="http://schemas.openxmlformats.org/drawingml/2006/main">
-            <a:pPr marL="0" indent="0" algn="l">
-              <a:buNone/>
-            </a:pPr>
-            <a:r>
-              <a:rPr sz="830">
-                <a:solidFill>
-                  <a:srgbClr val="69727E"/>
-                </a:solidFill>
-                <a:latin typeface="Aptos"/>
-                <a:ea typeface="Aptos"/>
-                <a:cs typeface="Aptos"/>
-              </a:rPr>
-              <a:t>公开证据：OpenAI Agents SDK PR #3642 · v0.17.7 release；GPT-5.6 Codex 使用情况来自贡献者研发记录</a:t>
-            </a:r>
-          </a:p>
-        </p:txBody>
-      </p:sp>
-      <p:sp>
-        <p:nvSpPr>
           <p:cNvPr id="41" name="Text 39">
             <a:extLst xmlns:a="http://schemas.openxmlformats.org/drawingml/2006/main">
               <a:ext uri="{FF2B5EF4-FFF2-40B4-BE49-F238E27FC236}">
@@ -15374,53 +15092,6 @@
       </p:sp>
       <p:sp>
         <p:nvSpPr>
-          <p:cNvPr id="29" name="Text 27">
-            <a:extLst xmlns:a="http://schemas.openxmlformats.org/drawingml/2006/main">
-              <a:ext uri="{FF2B5EF4-FFF2-40B4-BE49-F238E27FC236}">
-                <a16:creationId xmlns:a16="http://schemas.microsoft.com/office/drawing/2014/main" id="{985B666B-A084-4BAA-BAFF-0F1D83F40BDF}"/>
-              </a:ext>
-            </a:extLst>
-          </p:cNvPr>
-          <p:cNvSpPr>
-            <a:spLocks xmlns:a="http://schemas.openxmlformats.org/drawingml/2006/main" noGrp="1"/>
-          </p:cNvSpPr>
-          <p:nvPr/>
-        </p:nvSpPr>
-        <p:spPr>
-          <a:xfrm xmlns:a="http://schemas.openxmlformats.org/drawingml/2006/main">
-            <a:off x="530352" y="6547104"/>
-            <a:ext cx="9052560" cy="164592"/>
-          </a:xfrm>
-          <a:prstGeom xmlns:a="http://schemas.openxmlformats.org/drawingml/2006/main" prst="rect">
-            <a:avLst/>
-          </a:prstGeom>
-          <a:noFill xmlns:a="http://schemas.openxmlformats.org/drawingml/2006/main"/>
-        </p:spPr>
-        <p:txBody>
-          <a:bodyPr xmlns:a="http://schemas.openxmlformats.org/drawingml/2006/main" wrap="square" lIns="0" tIns="0" rIns="0" bIns="0" anchor="ctr">
-            <a:normAutofit fontScale="100000"/>
-          </a:bodyPr>
-          <a:lstStyle xmlns:a="http://schemas.openxmlformats.org/drawingml/2006/main"/>
-          <a:p xmlns:a="http://schemas.openxmlformats.org/drawingml/2006/main">
-            <a:pPr marL="0" indent="0" algn="l">
-              <a:buNone/>
-            </a:pPr>
-            <a:r>
-              <a:rPr sz="830">
-                <a:solidFill>
-                  <a:srgbClr val="69727E"/>
-                </a:solidFill>
-                <a:latin typeface="Aptos"/>
-                <a:ea typeface="Aptos"/>
-                <a:cs typeface="Aptos"/>
-              </a:rPr>
-              <a:t>产品判断基于 Jobs-to-be-Done；模型服务以用户授权与实际可用性为准</a:t>
-            </a:r>
-          </a:p>
-        </p:txBody>
-      </p:sp>
-      <p:sp>
-        <p:nvSpPr>
           <p:cNvPr id="30" name="Text 28">
             <a:extLst xmlns:a="http://schemas.openxmlformats.org/drawingml/2006/main">
               <a:ext uri="{FF2B5EF4-FFF2-40B4-BE49-F238E27FC236}">
@@ -17243,53 +16914,6 @@
       </p:sp>
       <p:sp>
         <p:nvSpPr>
-          <p:cNvPr id="42" name="Text 40">
-            <a:extLst xmlns:a="http://schemas.openxmlformats.org/drawingml/2006/main">
-              <a:ext uri="{FF2B5EF4-FFF2-40B4-BE49-F238E27FC236}">
-                <a16:creationId xmlns:a16="http://schemas.microsoft.com/office/drawing/2014/main" id="{9E7262FD-057B-4851-9DA2-496C5B276E0C}"/>
-              </a:ext>
-            </a:extLst>
-          </p:cNvPr>
-          <p:cNvSpPr>
-            <a:spLocks xmlns:a="http://schemas.openxmlformats.org/drawingml/2006/main" noGrp="1"/>
-          </p:cNvSpPr>
-          <p:nvPr/>
-        </p:nvSpPr>
-        <p:spPr>
-          <a:xfrm xmlns:a="http://schemas.openxmlformats.org/drawingml/2006/main">
-            <a:off x="530352" y="6547104"/>
-            <a:ext cx="9052560" cy="164592"/>
-          </a:xfrm>
-          <a:prstGeom xmlns:a="http://schemas.openxmlformats.org/drawingml/2006/main" prst="rect">
-            <a:avLst/>
-          </a:prstGeom>
-          <a:noFill xmlns:a="http://schemas.openxmlformats.org/drawingml/2006/main"/>
-        </p:spPr>
-        <p:txBody>
-          <a:bodyPr xmlns:a="http://schemas.openxmlformats.org/drawingml/2006/main" wrap="square" lIns="0" tIns="0" rIns="0" bIns="0" anchor="ctr">
-            <a:normAutofit/>
-          </a:bodyPr>
-          <a:lstStyle xmlns:a="http://schemas.openxmlformats.org/drawingml/2006/main"/>
-          <a:p xmlns:a="http://schemas.openxmlformats.org/drawingml/2006/main">
-            <a:pPr marL="0" indent="0" algn="l">
-              <a:buNone/>
-            </a:pPr>
-            <a:r>
-              <a:rPr sz="830">
-                <a:solidFill>
-                  <a:srgbClr val="69727E"/>
-                </a:solidFill>
-                <a:latin typeface="Aptos"/>
-                <a:ea typeface="Aptos"/>
-                <a:cs typeface="Aptos"/>
-              </a:rPr>
-              <a:t>商业方案为待验证实验；额度、周期和风控阈值需按 Cohort 数据迭代</a:t>
-            </a:r>
-          </a:p>
-        </p:txBody>
-      </p:sp>
-      <p:sp>
-        <p:nvSpPr>
           <p:cNvPr id="43" name="Text 41">
             <a:extLst xmlns:a="http://schemas.openxmlformats.org/drawingml/2006/main">
               <a:ext uri="{FF2B5EF4-FFF2-40B4-BE49-F238E27FC236}">
@@ -18682,53 +18306,6 @@
                 <a:cs typeface="PingFang SC"/>
               </a:rPr>
               <a:t>12 周内只验证三件事：稳定发布、真实激活、单位经济成立。</a:t>
-            </a:r>
-          </a:p>
-        </p:txBody>
-      </p:sp>
-      <p:sp>
-        <p:nvSpPr>
-          <p:cNvPr id="44" name="Text 42">
-            <a:extLst xmlns:a="http://schemas.openxmlformats.org/drawingml/2006/main">
-              <a:ext uri="{FF2B5EF4-FFF2-40B4-BE49-F238E27FC236}">
-                <a16:creationId xmlns:a16="http://schemas.microsoft.com/office/drawing/2014/main" id="{34A6504C-4520-4CEC-9ABE-FC9FE77A7C75}"/>
-              </a:ext>
-            </a:extLst>
-          </p:cNvPr>
-          <p:cNvSpPr>
-            <a:spLocks xmlns:a="http://schemas.openxmlformats.org/drawingml/2006/main" noGrp="1"/>
-          </p:cNvSpPr>
-          <p:nvPr/>
-        </p:nvSpPr>
-        <p:spPr>
-          <a:xfrm xmlns:a="http://schemas.openxmlformats.org/drawingml/2006/main">
-            <a:off x="530352" y="6547104"/>
-            <a:ext cx="9052560" cy="164592"/>
-          </a:xfrm>
-          <a:prstGeom xmlns:a="http://schemas.openxmlformats.org/drawingml/2006/main" prst="rect">
-            <a:avLst/>
-          </a:prstGeom>
-          <a:noFill xmlns:a="http://schemas.openxmlformats.org/drawingml/2006/main"/>
-        </p:spPr>
-        <p:txBody>
-          <a:bodyPr xmlns:a="http://schemas.openxmlformats.org/drawingml/2006/main" wrap="square" lIns="0" tIns="0" rIns="0" bIns="0" anchor="ctr">
-            <a:normAutofit/>
-          </a:bodyPr>
-          <a:lstStyle xmlns:a="http://schemas.openxmlformats.org/drawingml/2006/main"/>
-          <a:p xmlns:a="http://schemas.openxmlformats.org/drawingml/2006/main">
-            <a:pPr marL="0" indent="0" algn="l">
-              <a:buNone/>
-            </a:pPr>
-            <a:r>
-              <a:rPr sz="830">
-                <a:solidFill>
-                  <a:srgbClr val="69727E"/>
-                </a:solidFill>
-                <a:latin typeface="Aptos"/>
-                <a:ea typeface="Aptos"/>
-                <a:cs typeface="Aptos"/>
-              </a:rPr>
-              <a:t>路线图优先级：稳定发布 → 真实激活 → 留存与单位经济</a:t>
             </a:r>
           </a:p>
         </p:txBody>
@@ -18818,7 +18395,7 @@
           <p:nvPr/>
         </p:nvPicPr>
         <p:blipFill>
-          <a:blip xmlns:r="http://schemas.openxmlformats.org/officeDocument/2006/relationships" xmlns:a="http://schemas.openxmlformats.org/drawingml/2006/main" r:embed="R26ed591291b6440d"/>
+          <a:blip xmlns:r="http://schemas.openxmlformats.org/officeDocument/2006/relationships" xmlns:a="http://schemas.openxmlformats.org/drawingml/2006/main" r:embed="R56a0ceabe7044684"/>
           <a:stretch xmlns:a="http://schemas.openxmlformats.org/drawingml/2006/main">
             <a:fillRect l="0" t="0" r="0" b="0"/>
           </a:stretch>
@@ -20808,53 +20385,6 @@
       </p:sp>
       <p:sp>
         <p:nvSpPr>
-          <p:cNvPr id="22" name="Text 20">
-            <a:extLst xmlns:a="http://schemas.openxmlformats.org/drawingml/2006/main">
-              <a:ext uri="{FF2B5EF4-FFF2-40B4-BE49-F238E27FC236}">
-                <a16:creationId xmlns:a16="http://schemas.microsoft.com/office/drawing/2014/main" id="{1199097B-F714-475E-AD7D-D7C4AB8EE556}"/>
-              </a:ext>
-            </a:extLst>
-          </p:cNvPr>
-          <p:cNvSpPr>
-            <a:spLocks xmlns:a="http://schemas.openxmlformats.org/drawingml/2006/main" noGrp="1"/>
-          </p:cNvSpPr>
-          <p:nvPr/>
-        </p:nvSpPr>
-        <p:spPr>
-          <a:xfrm xmlns:a="http://schemas.openxmlformats.org/drawingml/2006/main">
-            <a:off x="530352" y="6547104"/>
-            <a:ext cx="9052560" cy="164592"/>
-          </a:xfrm>
-          <a:prstGeom xmlns:a="http://schemas.openxmlformats.org/drawingml/2006/main" prst="rect">
-            <a:avLst/>
-          </a:prstGeom>
-          <a:noFill xmlns:a="http://schemas.openxmlformats.org/drawingml/2006/main"/>
-        </p:spPr>
-        <p:txBody>
-          <a:bodyPr xmlns:a="http://schemas.openxmlformats.org/drawingml/2006/main" wrap="square" lIns="0" tIns="0" rIns="0" bIns="0" anchor="ctr">
-            <a:normAutofit/>
-          </a:bodyPr>
-          <a:lstStyle xmlns:a="http://schemas.openxmlformats.org/drawingml/2006/main"/>
-          <a:p xmlns:a="http://schemas.openxmlformats.org/drawingml/2006/main">
-            <a:pPr marL="0" indent="0" algn="l">
-              <a:buNone/>
-            </a:pPr>
-            <a:r>
-              <a:rPr sz="830">
-                <a:solidFill>
-                  <a:srgbClr val="69727E"/>
-                </a:solidFill>
-                <a:latin typeface="Aptos"/>
-                <a:ea typeface="Aptos"/>
-                <a:cs typeface="Aptos"/>
-              </a:rPr>
-              <a:t>产品原则：以任务到产物的闭环效率为主目标</a:t>
-            </a:r>
-          </a:p>
-        </p:txBody>
-      </p:sp>
-      <p:sp>
-        <p:nvSpPr>
           <p:cNvPr id="23" name="Text 21">
             <a:extLst xmlns:a="http://schemas.openxmlformats.org/drawingml/2006/main">
               <a:ext uri="{FF2B5EF4-FFF2-40B4-BE49-F238E27FC236}">
@@ -22758,53 +22288,6 @@
       </p:sp>
       <p:sp>
         <p:nvSpPr>
-          <p:cNvPr id="45" name="Text 43">
-            <a:extLst xmlns:a="http://schemas.openxmlformats.org/drawingml/2006/main">
-              <a:ext uri="{FF2B5EF4-FFF2-40B4-BE49-F238E27FC236}">
-                <a16:creationId xmlns:a16="http://schemas.microsoft.com/office/drawing/2014/main" id="{EDE03506-C5F0-4D0F-AFF0-D0F7B2F42228}"/>
-              </a:ext>
-            </a:extLst>
-          </p:cNvPr>
-          <p:cNvSpPr>
-            <a:spLocks xmlns:a="http://schemas.openxmlformats.org/drawingml/2006/main" noGrp="1"/>
-          </p:cNvSpPr>
-          <p:nvPr/>
-        </p:nvSpPr>
-        <p:spPr>
-          <a:xfrm xmlns:a="http://schemas.openxmlformats.org/drawingml/2006/main">
-            <a:off x="530352" y="6547104"/>
-            <a:ext cx="9052560" cy="164592"/>
-          </a:xfrm>
-          <a:prstGeom xmlns:a="http://schemas.openxmlformats.org/drawingml/2006/main" prst="rect">
-            <a:avLst/>
-          </a:prstGeom>
-          <a:noFill xmlns:a="http://schemas.openxmlformats.org/drawingml/2006/main"/>
-        </p:spPr>
-        <p:txBody>
-          <a:bodyPr xmlns:a="http://schemas.openxmlformats.org/drawingml/2006/main" wrap="square" lIns="0" tIns="0" rIns="0" bIns="0" anchor="ctr">
-            <a:normAutofit/>
-          </a:bodyPr>
-          <a:lstStyle xmlns:a="http://schemas.openxmlformats.org/drawingml/2006/main"/>
-          <a:p xmlns:a="http://schemas.openxmlformats.org/drawingml/2006/main">
-            <a:pPr marL="0" indent="0" algn="l">
-              <a:buNone/>
-            </a:pPr>
-            <a:r>
-              <a:rPr sz="830">
-                <a:solidFill>
-                  <a:srgbClr val="69727E"/>
-                </a:solidFill>
-                <a:latin typeface="Aptos"/>
-                <a:ea typeface="Aptos"/>
-                <a:cs typeface="Aptos"/>
-              </a:rPr>
-              <a:t>实现证据：provider connection · model discovery · protocol URL normalization</a:t>
-            </a:r>
-          </a:p>
-        </p:txBody>
-      </p:sp>
-      <p:sp>
-        <p:nvSpPr>
           <p:cNvPr id="46" name="Text 44">
             <a:extLst xmlns:a="http://schemas.openxmlformats.org/drawingml/2006/main">
               <a:ext uri="{FF2B5EF4-FFF2-40B4-BE49-F238E27FC236}">
@@ -23130,7 +22613,7 @@
           <p:nvPr/>
         </p:nvPicPr>
         <p:blipFill>
-          <a:blip xmlns:r="http://schemas.openxmlformats.org/officeDocument/2006/relationships" xmlns:a="http://schemas.openxmlformats.org/drawingml/2006/main" r:embed="R77eaa1ec5db7486b"/>
+          <a:blip xmlns:r="http://schemas.openxmlformats.org/officeDocument/2006/relationships" xmlns:a="http://schemas.openxmlformats.org/drawingml/2006/main" r:embed="R299c25cc417a4bc6"/>
           <a:stretch xmlns:a="http://schemas.openxmlformats.org/drawingml/2006/main">
             <a:fillRect l="0" t="0" r="0" b="0"/>
           </a:stretch>
@@ -24054,53 +23537,6 @@
                 <a:cs typeface="PingFang SC"/>
               </a:rPr>
               <a:t>规则、技能与记忆进入后续任务</a:t>
-            </a:r>
-          </a:p>
-        </p:txBody>
-      </p:sp>
-      <p:sp>
-        <p:nvSpPr>
-          <p:cNvPr id="30" name="Text 27">
-            <a:extLst xmlns:a="http://schemas.openxmlformats.org/drawingml/2006/main">
-              <a:ext uri="{FF2B5EF4-FFF2-40B4-BE49-F238E27FC236}">
-                <a16:creationId xmlns:a16="http://schemas.microsoft.com/office/drawing/2014/main" id="{B19992EB-4D13-448B-BB9C-BEEFB7BD4121}"/>
-              </a:ext>
-            </a:extLst>
-          </p:cNvPr>
-          <p:cNvSpPr>
-            <a:spLocks xmlns:a="http://schemas.openxmlformats.org/drawingml/2006/main" noGrp="1"/>
-          </p:cNvSpPr>
-          <p:nvPr/>
-        </p:nvSpPr>
-        <p:spPr>
-          <a:xfrm xmlns:a="http://schemas.openxmlformats.org/drawingml/2006/main">
-            <a:off x="530352" y="6547104"/>
-            <a:ext cx="9052560" cy="164592"/>
-          </a:xfrm>
-          <a:prstGeom xmlns:a="http://schemas.openxmlformats.org/drawingml/2006/main" prst="rect">
-            <a:avLst/>
-          </a:prstGeom>
-          <a:noFill xmlns:a="http://schemas.openxmlformats.org/drawingml/2006/main"/>
-        </p:spPr>
-        <p:txBody>
-          <a:bodyPr xmlns:a="http://schemas.openxmlformats.org/drawingml/2006/main" wrap="square" lIns="0" tIns="0" rIns="0" bIns="0" anchor="ctr">
-            <a:normAutofit/>
-          </a:bodyPr>
-          <a:lstStyle xmlns:a="http://schemas.openxmlformats.org/drawingml/2006/main"/>
-          <a:p xmlns:a="http://schemas.openxmlformats.org/drawingml/2006/main">
-            <a:pPr marL="0" indent="0" algn="l">
-              <a:buNone/>
-            </a:pPr>
-            <a:r>
-              <a:rPr sz="830">
-                <a:solidFill>
-                  <a:srgbClr val="69727E"/>
-                </a:solidFill>
-                <a:latin typeface="Aptos"/>
-                <a:ea typeface="Aptos"/>
-                <a:cs typeface="Aptos"/>
-              </a:rPr>
-              <a:t>现场演示使用当前 Mac Intel x86_64 构建</a:t>
             </a:r>
           </a:p>
         </p:txBody>
@@ -26186,53 +25622,6 @@
       </p:sp>
       <p:sp>
         <p:nvSpPr>
-          <p:cNvPr id="47" name="Text 45">
-            <a:extLst xmlns:a="http://schemas.openxmlformats.org/drawingml/2006/main">
-              <a:ext uri="{FF2B5EF4-FFF2-40B4-BE49-F238E27FC236}">
-                <a16:creationId xmlns:a16="http://schemas.microsoft.com/office/drawing/2014/main" id="{44CB6657-B55D-4254-8FC4-246477C90460}"/>
-              </a:ext>
-            </a:extLst>
-          </p:cNvPr>
-          <p:cNvSpPr>
-            <a:spLocks xmlns:a="http://schemas.openxmlformats.org/drawingml/2006/main" noGrp="1"/>
-          </p:cNvSpPr>
-          <p:nvPr/>
-        </p:nvSpPr>
-        <p:spPr>
-          <a:xfrm xmlns:a="http://schemas.openxmlformats.org/drawingml/2006/main">
-            <a:off x="530352" y="6547104"/>
-            <a:ext cx="9052560" cy="164592"/>
-          </a:xfrm>
-          <a:prstGeom xmlns:a="http://schemas.openxmlformats.org/drawingml/2006/main" prst="rect">
-            <a:avLst/>
-          </a:prstGeom>
-          <a:noFill xmlns:a="http://schemas.openxmlformats.org/drawingml/2006/main"/>
-        </p:spPr>
-        <p:txBody>
-          <a:bodyPr xmlns:a="http://schemas.openxmlformats.org/drawingml/2006/main" wrap="square" lIns="0" tIns="0" rIns="0" bIns="0" anchor="ctr">
-            <a:normAutofit fontScale="100000"/>
-          </a:bodyPr>
-          <a:lstStyle xmlns:a="http://schemas.openxmlformats.org/drawingml/2006/main"/>
-          <a:p xmlns:a="http://schemas.openxmlformats.org/drawingml/2006/main">
-            <a:pPr marL="0" indent="0" algn="l">
-              <a:buNone/>
-            </a:pPr>
-            <a:r>
-              <a:rPr sz="830">
-                <a:solidFill>
-                  <a:srgbClr val="69727E"/>
-                </a:solidFill>
-                <a:latin typeface="Aptos"/>
-                <a:ea typeface="Aptos"/>
-                <a:cs typeface="Aptos"/>
-              </a:rPr>
-              <a:t>当前实现证据：README · runtime adapter · EBAI capability tests</a:t>
-            </a:r>
-          </a:p>
-        </p:txBody>
-      </p:sp>
-      <p:sp>
-        <p:nvSpPr>
           <p:cNvPr id="48" name="Text 46">
             <a:extLst xmlns:a="http://schemas.openxmlformats.org/drawingml/2006/main">
               <a:ext uri="{FF2B5EF4-FFF2-40B4-BE49-F238E27FC236}">
@@ -27690,53 +27079,6 @@
       </p:sp>
       <p:sp>
         <p:nvSpPr>
-          <p:cNvPr id="33" name="Text 31">
-            <a:extLst xmlns:a="http://schemas.openxmlformats.org/drawingml/2006/main">
-              <a:ext uri="{FF2B5EF4-FFF2-40B4-BE49-F238E27FC236}">
-                <a16:creationId xmlns:a16="http://schemas.microsoft.com/office/drawing/2014/main" id="{2502E336-52FF-4EE1-AC0B-283859F22B37}"/>
-              </a:ext>
-            </a:extLst>
-          </p:cNvPr>
-          <p:cNvSpPr>
-            <a:spLocks xmlns:a="http://schemas.openxmlformats.org/drawingml/2006/main" noGrp="1"/>
-          </p:cNvSpPr>
-          <p:nvPr/>
-        </p:nvSpPr>
-        <p:spPr>
-          <a:xfrm xmlns:a="http://schemas.openxmlformats.org/drawingml/2006/main">
-            <a:off x="530352" y="6547104"/>
-            <a:ext cx="9052560" cy="164592"/>
-          </a:xfrm>
-          <a:prstGeom xmlns:a="http://schemas.openxmlformats.org/drawingml/2006/main" prst="rect">
-            <a:avLst/>
-          </a:prstGeom>
-          <a:noFill xmlns:a="http://schemas.openxmlformats.org/drawingml/2006/main"/>
-        </p:spPr>
-        <p:txBody>
-          <a:bodyPr xmlns:a="http://schemas.openxmlformats.org/drawingml/2006/main" wrap="square" lIns="0" tIns="0" rIns="0" bIns="0" anchor="ctr">
-            <a:normAutofit/>
-          </a:bodyPr>
-          <a:lstStyle xmlns:a="http://schemas.openxmlformats.org/drawingml/2006/main"/>
-          <a:p xmlns:a="http://schemas.openxmlformats.org/drawingml/2006/main">
-            <a:pPr marL="0" indent="0" algn="l">
-              <a:buNone/>
-            </a:pPr>
-            <a:r>
-              <a:rPr sz="830">
-                <a:solidFill>
-                  <a:srgbClr val="69727E"/>
-                </a:solidFill>
-                <a:latin typeface="Aptos"/>
-                <a:ea typeface="Aptos"/>
-                <a:cs typeface="Aptos"/>
-              </a:rPr>
-              <a:t>实现证据：runtime host · preload IPC · streaming adapter</a:t>
-            </a:r>
-          </a:p>
-        </p:txBody>
-      </p:sp>
-      <p:sp>
-        <p:nvSpPr>
           <p:cNvPr id="34" name="Text 32">
             <a:extLst xmlns:a="http://schemas.openxmlformats.org/drawingml/2006/main">
               <a:ext uri="{FF2B5EF4-FFF2-40B4-BE49-F238E27FC236}">
@@ -29117,53 +28459,6 @@
       </p:sp>
       <p:sp>
         <p:nvSpPr>
-          <p:cNvPr id="34" name="Text 32">
-            <a:extLst xmlns:a="http://schemas.openxmlformats.org/drawingml/2006/main">
-              <a:ext uri="{FF2B5EF4-FFF2-40B4-BE49-F238E27FC236}">
-                <a16:creationId xmlns:a16="http://schemas.microsoft.com/office/drawing/2014/main" id="{C3E50370-2ACE-42FC-844C-A16450168EF7}"/>
-              </a:ext>
-            </a:extLst>
-          </p:cNvPr>
-          <p:cNvSpPr>
-            <a:spLocks xmlns:a="http://schemas.openxmlformats.org/drawingml/2006/main" noGrp="1"/>
-          </p:cNvSpPr>
-          <p:nvPr/>
-        </p:nvSpPr>
-        <p:spPr>
-          <a:xfrm xmlns:a="http://schemas.openxmlformats.org/drawingml/2006/main">
-            <a:off x="530352" y="6547104"/>
-            <a:ext cx="9052560" cy="164592"/>
-          </a:xfrm>
-          <a:prstGeom xmlns:a="http://schemas.openxmlformats.org/drawingml/2006/main" prst="rect">
-            <a:avLst/>
-          </a:prstGeom>
-          <a:noFill xmlns:a="http://schemas.openxmlformats.org/drawingml/2006/main"/>
-        </p:spPr>
-        <p:txBody>
-          <a:bodyPr xmlns:a="http://schemas.openxmlformats.org/drawingml/2006/main" wrap="square" lIns="0" tIns="0" rIns="0" bIns="0" anchor="ctr">
-            <a:normAutofit fontScale="100000"/>
-          </a:bodyPr>
-          <a:lstStyle xmlns:a="http://schemas.openxmlformats.org/drawingml/2006/main"/>
-          <a:p xmlns:a="http://schemas.openxmlformats.org/drawingml/2006/main">
-            <a:pPr marL="0" indent="0" algn="l">
-              <a:buNone/>
-            </a:pPr>
-            <a:r>
-              <a:rPr sz="830">
-                <a:solidFill>
-                  <a:srgbClr val="69727E"/>
-                </a:solidFill>
-                <a:latin typeface="Aptos"/>
-                <a:ea typeface="Aptos"/>
-                <a:cs typeface="Aptos"/>
-              </a:rPr>
-              <a:t>实现依据：runtime host · streaming adapter · project-scoped state</a:t>
-            </a:r>
-          </a:p>
-        </p:txBody>
-      </p:sp>
-      <p:sp>
-        <p:nvSpPr>
           <p:cNvPr id="35" name="Text 33">
             <a:extLst xmlns:a="http://schemas.openxmlformats.org/drawingml/2006/main">
               <a:ext uri="{FF2B5EF4-FFF2-40B4-BE49-F238E27FC236}">
@@ -30785,53 +30080,6 @@
       </p:sp>
       <p:sp>
         <p:nvSpPr>
-          <p:cNvPr id="38" name="Text 36">
-            <a:extLst xmlns:a="http://schemas.openxmlformats.org/drawingml/2006/main">
-              <a:ext uri="{FF2B5EF4-FFF2-40B4-BE49-F238E27FC236}">
-                <a16:creationId xmlns:a16="http://schemas.microsoft.com/office/drawing/2014/main" id="{E8B27812-9FB8-4FA8-BEB8-D19592D72B13}"/>
-              </a:ext>
-            </a:extLst>
-          </p:cNvPr>
-          <p:cNvSpPr>
-            <a:spLocks xmlns:a="http://schemas.openxmlformats.org/drawingml/2006/main" noGrp="1"/>
-          </p:cNvSpPr>
-          <p:nvPr/>
-        </p:nvSpPr>
-        <p:spPr>
-          <a:xfrm xmlns:a="http://schemas.openxmlformats.org/drawingml/2006/main">
-            <a:off x="530352" y="6547104"/>
-            <a:ext cx="9052560" cy="164592"/>
-          </a:xfrm>
-          <a:prstGeom xmlns:a="http://schemas.openxmlformats.org/drawingml/2006/main" prst="rect">
-            <a:avLst/>
-          </a:prstGeom>
-          <a:noFill xmlns:a="http://schemas.openxmlformats.org/drawingml/2006/main"/>
-        </p:spPr>
-        <p:txBody>
-          <a:bodyPr xmlns:a="http://schemas.openxmlformats.org/drawingml/2006/main" wrap="square" lIns="0" tIns="0" rIns="0" bIns="0" anchor="ctr">
-            <a:normAutofit/>
-          </a:bodyPr>
-          <a:lstStyle xmlns:a="http://schemas.openxmlformats.org/drawingml/2006/main"/>
-          <a:p xmlns:a="http://schemas.openxmlformats.org/drawingml/2006/main">
-            <a:pPr marL="0" indent="0" algn="l">
-              <a:buNone/>
-            </a:pPr>
-            <a:r>
-              <a:rPr sz="830">
-                <a:solidFill>
-                  <a:srgbClr val="69727E"/>
-                </a:solidFill>
-                <a:latin typeface="Aptos"/>
-                <a:ea typeface="Aptos"/>
-                <a:cs typeface="Aptos"/>
-              </a:rPr>
-              <a:t>实现证据：stream normalization · progress timeline · failure sanitization tests</a:t>
-            </a:r>
-          </a:p>
-        </p:txBody>
-      </p:sp>
-      <p:sp>
-        <p:nvSpPr>
           <p:cNvPr id="39" name="Text 37">
             <a:extLst xmlns:a="http://schemas.openxmlformats.org/drawingml/2006/main">
               <a:ext uri="{FF2B5EF4-FFF2-40B4-BE49-F238E27FC236}">
@@ -32123,53 +31371,6 @@
                 <a:cs typeface="PingFang SC"/>
               </a:rPr>
               <a:t>遥测不可用时明确显示 unavailable，不把缺失数据包装成“节省 0%”。</a:t>
-            </a:r>
-          </a:p>
-        </p:txBody>
-      </p:sp>
-      <p:sp>
-        <p:nvSpPr>
-          <p:cNvPr id="31" name="Text 29">
-            <a:extLst xmlns:a="http://schemas.openxmlformats.org/drawingml/2006/main">
-              <a:ext uri="{FF2B5EF4-FFF2-40B4-BE49-F238E27FC236}">
-                <a16:creationId xmlns:a16="http://schemas.microsoft.com/office/drawing/2014/main" id="{4DCBE524-6CCE-4F1B-998B-293E38DA461D}"/>
-              </a:ext>
-            </a:extLst>
-          </p:cNvPr>
-          <p:cNvSpPr>
-            <a:spLocks xmlns:a="http://schemas.openxmlformats.org/drawingml/2006/main" noGrp="1"/>
-          </p:cNvSpPr>
-          <p:nvPr/>
-        </p:nvSpPr>
-        <p:spPr>
-          <a:xfrm xmlns:a="http://schemas.openxmlformats.org/drawingml/2006/main">
-            <a:off x="530352" y="6547104"/>
-            <a:ext cx="9052560" cy="164592"/>
-          </a:xfrm>
-          <a:prstGeom xmlns:a="http://schemas.openxmlformats.org/drawingml/2006/main" prst="rect">
-            <a:avLst/>
-          </a:prstGeom>
-          <a:noFill xmlns:a="http://schemas.openxmlformats.org/drawingml/2006/main"/>
-        </p:spPr>
-        <p:txBody>
-          <a:bodyPr xmlns:a="http://schemas.openxmlformats.org/drawingml/2006/main" wrap="square" lIns="0" tIns="0" rIns="0" bIns="0" anchor="ctr">
-            <a:normAutofit fontScale="100000"/>
-          </a:bodyPr>
-          <a:lstStyle xmlns:a="http://schemas.openxmlformats.org/drawingml/2006/main"/>
-          <a:p xmlns:a="http://schemas.openxmlformats.org/drawingml/2006/main">
-            <a:pPr marL="0" indent="0" algn="l">
-              <a:buNone/>
-            </a:pPr>
-            <a:r>
-              <a:rPr sz="830">
-                <a:solidFill>
-                  <a:srgbClr val="69727E"/>
-                </a:solidFill>
-                <a:latin typeface="Aptos"/>
-                <a:ea typeface="Aptos"/>
-                <a:cs typeface="Aptos"/>
-              </a:rPr>
-              <a:t>实现证据：app settings · IPC schema · normalizer · usage telemetry guards</a:t>
             </a:r>
           </a:p>
         </p:txBody>

</xml_diff>